<commit_message>
deck: add 'Step 0: earliest arrival' TD-Dijkstra slide (pseudocode codebox, FIFO correctness, where-it-runs) before the Bv slide; plain-words intro on Bv slide
</commit_message>
<xml_diff>
--- a/experiments/20260804-budget-conditioning/ppt/sensing_routing_method_and_results.pptx
+++ b/experiments/20260804-budget-conditioning/ppt/sensing_routing_method_and_results.pptx
@@ -29,6 +29,7 @@
     <p:sldId id="342" r:id="rId36"/>
     <p:sldId id="343" r:id="rId37"/>
     <p:sldId id="344" r:id="rId38"/>
+    <p:sldId id="345" r:id="rId39"/>
   </p:sldIdLst>
   <p:sldSz cx="12192000" cy="6858000"/>
   <p:notesSz cx="6858000" cy="9144000"/>
@@ -8056,7 +8057,7 @@
           <a:p>
             <a:r>
               <a:rPr lang="en-US" altLang="zh-CN" sz="2800" dirty="0"/>
-              <a:t>How Bᵥ is set</a:t>
+              <a:t>Step 0: earliest arrival</a:t>
             </a:r>
             <a:endParaRPr lang="zh-CN" altLang="en-US" sz="2800" dirty="0"/>
           </a:p>
@@ -8070,8 +8071,8 @@
         </p:nvSpPr>
         <p:spPr>
           <a:xfrm>
-            <a:off x="685800" y="1371600"/>
-            <a:ext cx="10789920" cy="274320"/>
+            <a:off x="685800" y="1353312"/>
+            <a:ext cx="10881360" cy="274320"/>
           </a:xfrm>
           <a:prstGeom prst="rect">
             <a:avLst/>
@@ -8092,59 +8093,312 @@
               </a:defRPr>
             </a:pPr>
             <a:r>
-              <a:t>Bᵥ is NOT a fixed constant — it is derived per vehicle, per instance, from a slack ratio ρᵥ:</a:t>
+              <a:t>Before any budget can be set, we must know the fastest this vehicle could possibly make its trip TODAY — earliest arrival on the current network, under this case's congestion δ. One run per vehicle:</a:t>
             </a:r>
           </a:p>
         </p:txBody>
       </p:sp>
-      <p:pic>
-        <p:nvPicPr>
-          <p:cNvPr id="205" name="Picture 204" descr="eq_budget.png"/>
-          <p:cNvPicPr>
-            <a:picLocks noChangeAspect="1"/>
-          </p:cNvPicPr>
+      <p:sp>
+        <p:nvSpPr>
+          <p:cNvPr id="205" name="Rounded Rectangle 204"/>
+          <p:cNvSpPr/>
           <p:nvPr/>
-        </p:nvPicPr>
-        <p:blipFill>
-          <a:blip r:embed="rId2"/>
-          <a:stretch>
-            <a:fillRect/>
-          </a:stretch>
-        </p:blipFill>
+        </p:nvSpPr>
         <p:spPr>
           <a:xfrm>
-            <a:off x="3618865" y="1737360"/>
-            <a:ext cx="4953965" cy="365760"/>
+            <a:off x="685800" y="1956816"/>
+            <a:ext cx="8321040" cy="2514600"/>
           </a:xfrm>
-          <a:prstGeom prst="rect">
-            <a:avLst/>
+          <a:prstGeom prst="roundRect">
+            <a:avLst>
+              <a:gd name="adj" fmla="val 4000"/>
+            </a:avLst>
           </a:prstGeom>
+          <a:solidFill>
+            <a:srgbClr val="F7F7F5"/>
+          </a:solidFill>
+          <a:ln w="15240">
+            <a:solidFill>
+              <a:srgbClr val="C9C8C2"/>
+            </a:solidFill>
+          </a:ln>
+          <a:effectLst/>
         </p:spPr>
-      </p:pic>
-      <p:pic>
-        <p:nvPicPr>
-          <p:cNvPr id="206" name="Picture 205" descr="eq_taumin.png"/>
-          <p:cNvPicPr>
-            <a:picLocks noChangeAspect="1"/>
-          </p:cNvPicPr>
+        <p:style>
+          <a:lnRef idx="1">
+            <a:schemeClr val="accent1"/>
+          </a:lnRef>
+          <a:fillRef idx="3">
+            <a:schemeClr val="accent1"/>
+          </a:fillRef>
+          <a:effectRef idx="2">
+            <a:schemeClr val="accent1"/>
+          </a:effectRef>
+          <a:fontRef idx="minor">
+            <a:schemeClr val="lt1"/>
+          </a:fontRef>
+        </p:style>
+        <p:txBody>
+          <a:bodyPr rtlCol="0" anchor="ctr" wrap="none" lIns="128016" rIns="128016" tIns="54864" bIns="54864"/>
+          <a:lstStyle/>
+          <a:p>
+            <a:pPr algn="l">
+              <a:defRPr sz="960" b="1">
+                <a:solidFill>
+                  <a:srgbClr val="EB6834"/>
+                </a:solidFill>
+                <a:latin typeface="Courier New"/>
+              </a:defRPr>
+            </a:pPr>
+            <a:r>
+              <a:t>EarliestArrival(o, t₀, δ):        # one run per vehicle, on today's network</a:t>
+            </a:r>
+          </a:p>
+          <a:p>
+            <a:pPr algn="l">
+              <a:defRPr sz="960" b="0">
+                <a:solidFill>
+                  <a:srgbClr val="0B0B0B"/>
+                </a:solidFill>
+                <a:latin typeface="Courier New"/>
+              </a:defRPr>
+            </a:pPr>
+            <a:r>
+              <a:t>  entry[l] ← t₀  for every link l leaving gate o;  push (t₀, l)</a:t>
+            </a:r>
+          </a:p>
+          <a:p>
+            <a:pPr algn="l">
+              <a:defRPr sz="960" b="0">
+                <a:solidFill>
+                  <a:srgbClr val="0B0B0B"/>
+                </a:solidFill>
+                <a:latin typeface="Courier New"/>
+              </a:defRPr>
+            </a:pPr>
+            <a:r>
+              <a:t>  while queue not empty:</a:t>
+            </a:r>
+          </a:p>
+          <a:p>
+            <a:pPr algn="l">
+              <a:defRPr sz="960" b="0">
+                <a:solidFill>
+                  <a:srgbClr val="0B0B0B"/>
+                </a:solidFill>
+                <a:latin typeface="Courier New"/>
+              </a:defRPr>
+            </a:pPr>
+            <a:r>
+              <a:t>      (t, l) ← pop the SMALLEST entry time     # ordinary Dijkstra order</a:t>
+            </a:r>
+          </a:p>
+          <a:p>
+            <a:pPr algn="l">
+              <a:defRPr sz="960" b="0">
+                <a:solidFill>
+                  <a:srgbClr val="0B0B0B"/>
+                </a:solidFill>
+                <a:latin typeface="Courier New"/>
+              </a:defRPr>
+            </a:pPr>
+            <a:r>
+              <a:t>      if t &gt; entry[l]: continue                # stale label</a:t>
+            </a:r>
+          </a:p>
+          <a:p>
+            <a:pPr algn="l">
+              <a:defRPr sz="960" b="1">
+                <a:solidFill>
+                  <a:srgbClr val="EB6834"/>
+                </a:solidFill>
+                <a:latin typeface="Courier New"/>
+              </a:defRPr>
+            </a:pPr>
+            <a:r>
+              <a:t>      s ← t + c(l, t)      # exit time; the clock is INSIDE the cost</a:t>
+            </a:r>
+          </a:p>
+          <a:p>
+            <a:pPr algn="l">
+              <a:defRPr sz="960" b="0">
+                <a:solidFill>
+                  <a:srgbClr val="0B0B0B"/>
+                </a:solidFill>
+                <a:latin typeface="Courier New"/>
+              </a:defRPr>
+            </a:pPr>
+            <a:r>
+              <a:t>      if l ends at a gate g:  arrive[g] ← min(arrive[g], s)</a:t>
+            </a:r>
+          </a:p>
+          <a:p>
+            <a:pPr algn="l">
+              <a:defRPr sz="960" b="0">
+                <a:solidFill>
+                  <a:srgbClr val="0B0B0B"/>
+                </a:solidFill>
+                <a:latin typeface="Courier New"/>
+              </a:defRPr>
+            </a:pPr>
+            <a:r>
+              <a:t>      for every successor j of l (no U-turn):</a:t>
+            </a:r>
+          </a:p>
+          <a:p>
+            <a:pPr algn="l">
+              <a:defRPr sz="960" b="0">
+                <a:solidFill>
+                  <a:srgbClr val="0B0B0B"/>
+                </a:solidFill>
+                <a:latin typeface="Courier New"/>
+              </a:defRPr>
+            </a:pPr>
+            <a:r>
+              <a:t>          if s &lt; entry[j]:  entry[j] ← s;  push (s, j)</a:t>
+            </a:r>
+          </a:p>
+          <a:p>
+            <a:pPr algn="l">
+              <a:defRPr sz="960" b="0">
+                <a:solidFill>
+                  <a:srgbClr val="0B0B0B"/>
+                </a:solidFill>
+                <a:latin typeface="Courier New"/>
+              </a:defRPr>
+            </a:pPr>
+            <a:r>
+              <a:t>  return arrive                               # earliest arrival at EVERY gate</a:t>
+            </a:r>
+          </a:p>
+          <a:p>
+            <a:pPr algn="l">
+              <a:defRPr sz="960" b="0">
+                <a:solidFill>
+                  <a:srgbClr val="0B0B0B"/>
+                </a:solidFill>
+                <a:latin typeface="Courier New"/>
+              </a:defRPr>
+            </a:pPr>
+          </a:p>
+          <a:p>
+            <a:pPr algn="l">
+              <a:defRPr sz="960" b="1">
+                <a:solidFill>
+                  <a:srgbClr val="EB6834"/>
+                </a:solidFill>
+                <a:latin typeface="Courier New"/>
+              </a:defRPr>
+            </a:pPr>
+            <a:r>
+              <a:t>τᵐⁱⁿ_v = arrive[d_v] − t₀_v</a:t>
+            </a:r>
+          </a:p>
+        </p:txBody>
+      </p:sp>
+      <p:sp>
+        <p:nvSpPr>
+          <p:cNvPr id="206" name="Rounded Rectangle 205"/>
+          <p:cNvSpPr/>
           <p:nvPr/>
-        </p:nvPicPr>
-        <p:blipFill>
-          <a:blip r:embed="rId3"/>
-          <a:stretch>
-            <a:fillRect/>
-          </a:stretch>
-        </p:blipFill>
+        </p:nvSpPr>
         <p:spPr>
           <a:xfrm>
-            <a:off x="1918544" y="2212848"/>
-            <a:ext cx="8354607" cy="329184"/>
+            <a:off x="9235440" y="1956816"/>
+            <a:ext cx="2468880" cy="2514600"/>
           </a:xfrm>
-          <a:prstGeom prst="rect">
-            <a:avLst/>
+          <a:prstGeom prst="roundRect">
+            <a:avLst>
+              <a:gd name="adj" fmla="val 10000"/>
+            </a:avLst>
           </a:prstGeom>
+          <a:solidFill>
+            <a:srgbClr val="FDF1E9"/>
+          </a:solidFill>
+          <a:ln w="15240">
+            <a:solidFill>
+              <a:srgbClr val="EB6834"/>
+            </a:solidFill>
+          </a:ln>
+          <a:effectLst/>
         </p:spPr>
-      </p:pic>
+        <p:style>
+          <a:lnRef idx="1">
+            <a:schemeClr val="accent1"/>
+          </a:lnRef>
+          <a:fillRef idx="3">
+            <a:schemeClr val="accent1"/>
+          </a:fillRef>
+          <a:effectRef idx="2">
+            <a:schemeClr val="accent1"/>
+          </a:effectRef>
+          <a:fontRef idx="minor">
+            <a:schemeClr val="lt1"/>
+          </a:fontRef>
+        </p:style>
+        <p:txBody>
+          <a:bodyPr rtlCol="0" anchor="ctr" wrap="square" lIns="54864" rIns="54864" tIns="27432" bIns="27432"/>
+          <a:lstStyle/>
+          <a:p>
+            <a:pPr algn="ctr">
+              <a:defRPr sz="1050" b="1">
+                <a:solidFill>
+                  <a:srgbClr val="EB6834"/>
+                </a:solidFill>
+              </a:defRPr>
+            </a:pPr>
+            <a:r>
+              <a:t>Where it runs</a:t>
+            </a:r>
+          </a:p>
+          <a:p>
+            <a:pPr algn="ctr">
+              <a:defRPr sz="860">
+                <a:solidFill>
+                  <a:srgbClr val="52514E"/>
+                </a:solidFill>
+              </a:defRPr>
+            </a:pPr>
+            <a:r>
+              <a:t>① budget assignment:</a:t>
+            </a:r>
+            <a:br/>
+            <a:r>
+              <a:t>V runs per case</a:t>
+            </a:r>
+            <a:br/>
+            <a:r>
+              <a:t>(~41 000 in the farm)</a:t>
+            </a:r>
+            <a:br/>
+            <a:br/>
+            <a:r>
+              <a:t>② decoder mask:</a:t>
+            </a:r>
+            <a:br/>
+            <a:r>
+              <a:t>min_finish(l, t, d) —</a:t>
+            </a:r>
+            <a:br/>
+            <a:r>
+              <a:t>same algorithm from one</a:t>
+            </a:r>
+            <a:br/>
+            <a:r>
+              <a:t>link, memoised</a:t>
+            </a:r>
+            <a:br/>
+            <a:br/>
+            <a:r>
+              <a:t>③ horizon calibration:</a:t>
+            </a:r>
+            <a:br/>
+            <a:r>
+              <a:t>once, all 8 gates</a:t>
+            </a:r>
+          </a:p>
+        </p:txBody>
+      </p:sp>
       <p:sp>
         <p:nvSpPr>
           <p:cNvPr id="207" name="TextBox 206"/>
@@ -8153,8 +8407,8 @@
         </p:nvSpPr>
         <p:spPr>
           <a:xfrm>
-            <a:off x="640080" y="2724912"/>
-            <a:ext cx="10972800" cy="914400"/>
+            <a:off x="640080" y="4709160"/>
+            <a:ext cx="11064240" cy="914400"/>
           </a:xfrm>
           <a:prstGeom prst="rect">
             <a:avLst/>
@@ -8168,50 +8422,26 @@
           <a:lstStyle/>
           <a:p>
             <a:pPr>
-              <a:defRPr sz="1250" b="0"/>
+              <a:defRPr sz="1200" b="1"/>
             </a:pPr>
             <a:r>
-              <a:t>• Step 1 — draw the slack ratio ρᵥ.  Training farm: per vehicle from the anchors {1.0, 1.5, 2.0, 3.0}; in 35 % of fleets all vehicles share one ρ (homogeneous), in 65 % each vehicle draws its own (heterogeneous). At TEST time ρ is arbitrary — including values never seen in training ({1.25, 1.75} interpolation, 4.0 extrapolation)</a:t>
+              <a:t>• It is ordinary Dijkstra with ONE change: a label is a time, not a distance, and relaxing link l entered at time t costs c(l, t) — today's congestion δ sits inside c</a:t>
             </a:r>
           </a:p>
           <a:p>
             <a:pPr>
-              <a:defRPr sz="1250" b="0"/>
+              <a:defRPr sz="1200" b="0"/>
             </a:pPr>
             <a:r>
-              <a:t>• Step 2 — compute the feasibility floor τᵐⁱⁿᵥ.  Earliest arrival o→d departing at t₀ under THIS instance's congestion δ (time-dependent Dijkstra) — instance-specific, not a table lookup</a:t>
+              <a:t>• Why the greedy order stays correct: our costs are FIFO — t + c(l, t) never decreases in t (entering later can never mean exiting earlier), so the first label popped for a link is final, exactly the classic Dijkstra invariant</a:t>
             </a:r>
           </a:p>
           <a:p>
             <a:pPr>
-              <a:defRPr sz="1250" b="0"/>
+              <a:defRPr sz="1200" b="0"/>
             </a:pPr>
             <a:r>
-              <a:t>• Step 3 — Bᵥ = ⌈ρᵥ · τᵐⁱⁿᵥ⌉, floored at τᵐⁱⁿᵥ (a task is never born infeasible) and capped at H − t₀ᵥ (never beyond the coverage grid)</a:t>
-            </a:r>
-          </a:p>
-          <a:p>
-            <a:pPr>
-              <a:defRPr sz="1250" b="1"/>
-            </a:pPr>
-            <a:r>
-              <a:t>• Why a RATIO and not an absolute number: the same B = 100 is vacuous for a near OD (τᵐⁱⁿ = 14) and infeasible for a far one (τᵐⁱⁿ = 120). ρ is comparable across all ODs:  ρ = 1 ⇔ exactly the min-time trip;  ρ = 2 ⇔ twice the minimum time</a:t>
-            </a:r>
-          </a:p>
-          <a:p>
-            <a:pPr>
-              <a:defRPr sz="1250" b="0"/>
-            </a:pPr>
-            <a:r>
-              <a:t>• Worked example (the sweep instance, V = 3, τᵐⁱⁿ = [38, 120, 14]):  ρ = 1.5 for all ⇒  B = [57, 180, 21] — same slack semantics, very different absolute budgets</a:t>
-            </a:r>
-          </a:p>
-          <a:p>
-            <a:pPr>
-              <a:defRPr sz="1250" b="1"/>
-            </a:pPr>
-            <a:r>
-              <a:t>• Bᵥ then enters BOTH sides of the pipeline: the MILP constraint (labels) and the model input (conditioning) + the decoder feasibility mask</a:t>
+              <a:t>• One run touches at most 80 links → microseconds; ~41 000 runs across the whole farm are negligible next to the 0.90 s MILP solves. The mask's memoised queries are part of the 6–9 ms inference time</a:t>
             </a:r>
           </a:p>
         </p:txBody>
@@ -8334,6 +8564,246 @@
 </file>
 
 <file path=ppt/slides/slide20.xml><?xml version="1.0" encoding="utf-8"?>
+<p:sld xmlns:a="http://schemas.openxmlformats.org/drawingml/2006/main" xmlns:p="http://schemas.openxmlformats.org/presentationml/2006/main" xmlns:r="http://schemas.openxmlformats.org/officeDocument/2006/relationships">
+  <p:cSld>
+    <p:spTree>
+      <p:nvGrpSpPr>
+        <p:cNvPr id="1" name=""/>
+        <p:cNvGrpSpPr/>
+        <p:nvPr/>
+      </p:nvGrpSpPr>
+      <p:grpSpPr/>
+      <p:sp>
+        <p:nvSpPr>
+          <p:cNvPr id="7" name="文本占位符 6">
+            <a:extLst>
+              <a:ext uri="{FF2B5EF4-FFF2-40B4-BE49-F238E27FC236}">
+                <a16:creationId xmlns:a16="http://schemas.microsoft.com/office/drawing/2014/main" id="{33AE8DB3-4C29-0DE3-EB73-8D2BBFBB8CBF}"/>
+              </a:ext>
+            </a:extLst>
+          </p:cNvPr>
+          <p:cNvSpPr>
+            <a:spLocks noGrp="1"/>
+          </p:cNvSpPr>
+          <p:nvPr>
+            <p:ph type="body" sz="quarter" idx="11"/>
+          </p:nvPr>
+        </p:nvSpPr>
+        <p:spPr>
+          <a:xfrm>
+            <a:off x="336550" y="58738"/>
+            <a:ext cx="5759450" cy="622300"/>
+          </a:xfrm>
+        </p:spPr>
+        <p:txBody>
+          <a:bodyPr/>
+          <a:lstStyle/>
+          <a:p>
+            <a:r>
+              <a:rPr lang="en-US" altLang="zh-CN" dirty="0"/>
+              <a:t>Change (a) — objective</a:t>
+            </a:r>
+            <a:endParaRPr lang="zh-CN" altLang="en-US" dirty="0"/>
+          </a:p>
+        </p:txBody>
+      </p:sp>
+      <p:sp>
+        <p:nvSpPr>
+          <p:cNvPr id="203" name="文本占位符 5">
+            <a:extLst>
+              <a:ext uri="{FF2B5EF4-FFF2-40B4-BE49-F238E27FC236}">
+                <a16:creationId xmlns:a16="http://schemas.microsoft.com/office/drawing/2014/main" id="{A219F0BA-71F5-BA11-CCBD-9327897B98CC}"/>
+              </a:ext>
+            </a:extLst>
+          </p:cNvPr>
+          <p:cNvSpPr>
+            <a:spLocks noGrp="1"/>
+          </p:cNvSpPr>
+          <p:nvPr>
+            <p:ph type="body" sz="quarter" idx="10"/>
+          </p:nvPr>
+        </p:nvSpPr>
+        <p:spPr>
+          <a:xfrm>
+            <a:off x="0" y="820290"/>
+            <a:ext cx="5878224" cy="638175"/>
+          </a:xfrm>
+        </p:spPr>
+        <p:txBody>
+          <a:bodyPr/>
+          <a:lstStyle/>
+          <a:p>
+            <a:r>
+              <a:rPr lang="en-US" altLang="zh-CN" sz="2800" dirty="0"/>
+              <a:t>How Bᵥ is set</a:t>
+            </a:r>
+            <a:endParaRPr lang="zh-CN" altLang="en-US" sz="2800" dirty="0"/>
+          </a:p>
+        </p:txBody>
+      </p:sp>
+      <p:sp>
+        <p:nvSpPr>
+          <p:cNvPr id="204" name="TextBox 203"/>
+          <p:cNvSpPr txBox="1"/>
+          <p:nvPr/>
+        </p:nvSpPr>
+        <p:spPr>
+          <a:xfrm>
+            <a:off x="685800" y="1353312"/>
+            <a:ext cx="10881360" cy="274320"/>
+          </a:xfrm>
+          <a:prstGeom prst="rect">
+            <a:avLst/>
+          </a:prstGeom>
+          <a:noFill/>
+        </p:spPr>
+        <p:txBody>
+          <a:bodyPr wrap="square">
+            <a:spAutoFit/>
+          </a:bodyPr>
+          <a:lstStyle/>
+          <a:p>
+            <a:pPr algn="l">
+              <a:defRPr sz="1250" b="1">
+                <a:solidFill>
+                  <a:srgbClr val="52514E"/>
+                </a:solidFill>
+              </a:defRPr>
+            </a:pPr>
+            <a:r>
+              <a:t>In plain words: first compute the fastest this vehicle could make its trip today (τᵐⁱⁿᵥ, previous slide); the budget is that minimum times a slack factor — 'you get ρ× the minimum time'. Not a fixed constant: derived per vehicle, per instance.</a:t>
+            </a:r>
+          </a:p>
+        </p:txBody>
+      </p:sp>
+      <p:pic>
+        <p:nvPicPr>
+          <p:cNvPr id="205" name="Picture 204" descr="eq_budget.png"/>
+          <p:cNvPicPr>
+            <a:picLocks noChangeAspect="1"/>
+          </p:cNvPicPr>
+          <p:nvPr/>
+        </p:nvPicPr>
+        <p:blipFill>
+          <a:blip r:embed="rId2"/>
+          <a:stretch>
+            <a:fillRect/>
+          </a:stretch>
+        </p:blipFill>
+        <p:spPr>
+          <a:xfrm>
+            <a:off x="3618865" y="1883664"/>
+            <a:ext cx="4953965" cy="365760"/>
+          </a:xfrm>
+          <a:prstGeom prst="rect">
+            <a:avLst/>
+          </a:prstGeom>
+        </p:spPr>
+      </p:pic>
+      <p:pic>
+        <p:nvPicPr>
+          <p:cNvPr id="206" name="Picture 205" descr="eq_taumin.png"/>
+          <p:cNvPicPr>
+            <a:picLocks noChangeAspect="1"/>
+          </p:cNvPicPr>
+          <p:nvPr/>
+        </p:nvPicPr>
+        <p:blipFill>
+          <a:blip r:embed="rId3"/>
+          <a:stretch>
+            <a:fillRect/>
+          </a:stretch>
+        </p:blipFill>
+        <p:spPr>
+          <a:xfrm>
+            <a:off x="1918544" y="2359152"/>
+            <a:ext cx="8354607" cy="329184"/>
+          </a:xfrm>
+          <a:prstGeom prst="rect">
+            <a:avLst/>
+          </a:prstGeom>
+        </p:spPr>
+      </p:pic>
+      <p:sp>
+        <p:nvSpPr>
+          <p:cNvPr id="207" name="TextBox 206"/>
+          <p:cNvSpPr txBox="1"/>
+          <p:nvPr/>
+        </p:nvSpPr>
+        <p:spPr>
+          <a:xfrm>
+            <a:off x="640080" y="2852928"/>
+            <a:ext cx="10972800" cy="914400"/>
+          </a:xfrm>
+          <a:prstGeom prst="rect">
+            <a:avLst/>
+          </a:prstGeom>
+          <a:noFill/>
+        </p:spPr>
+        <p:txBody>
+          <a:bodyPr wrap="square">
+            <a:spAutoFit/>
+          </a:bodyPr>
+          <a:lstStyle/>
+          <a:p>
+            <a:pPr>
+              <a:defRPr sz="1250" b="0"/>
+            </a:pPr>
+            <a:r>
+              <a:t>• Step 1 — draw the slack ratio ρᵥ.  Training farm: per vehicle from the anchors {1.0, 1.5, 2.0, 3.0}; in 35 % of fleets all vehicles share one ρ (homogeneous), in 65 % each vehicle draws its own (heterogeneous). At TEST time ρ is arbitrary — including values never seen in training ({1.25, 1.75} interpolation, 4.0 extrapolation)</a:t>
+            </a:r>
+          </a:p>
+          <a:p>
+            <a:pPr>
+              <a:defRPr sz="1250" b="0"/>
+            </a:pPr>
+            <a:r>
+              <a:t>• Step 2 — the feasibility floor τᵐⁱⁿᵥ comes from the TD-Dijkstra run of the previous slide (earliest arrival o→d departing at t₀ under THIS instance's δ) — instance-specific, not a table lookup</a:t>
+            </a:r>
+          </a:p>
+          <a:p>
+            <a:pPr>
+              <a:defRPr sz="1250" b="0"/>
+            </a:pPr>
+            <a:r>
+              <a:t>• Step 3 — Bᵥ = ⌈ρᵥ · τᵐⁱⁿᵥ⌉, floored at τᵐⁱⁿᵥ (a task is never born infeasible) and capped at H − t₀ᵥ (never beyond the coverage grid)</a:t>
+            </a:r>
+          </a:p>
+          <a:p>
+            <a:pPr>
+              <a:defRPr sz="1250" b="1"/>
+            </a:pPr>
+            <a:r>
+              <a:t>• Why a RATIO and not an absolute number: the same B = 100 is vacuous for a near OD (τᵐⁱⁿ = 14) and infeasible for a far one (τᵐⁱⁿ = 120). ρ is comparable across all ODs:  ρ = 1 ⇔ exactly the min-time trip;  ρ = 2 ⇔ twice the minimum time</a:t>
+            </a:r>
+          </a:p>
+          <a:p>
+            <a:pPr>
+              <a:defRPr sz="1250" b="0"/>
+            </a:pPr>
+            <a:r>
+              <a:t>• Worked example (the sweep instance, V = 3, τᵐⁱⁿ = [38, 120, 14]):  ρ = 1.5 for all ⇒  B = [57, 180, 21] — same slack semantics, very different absolute budgets</a:t>
+            </a:r>
+          </a:p>
+          <a:p>
+            <a:pPr>
+              <a:defRPr sz="1250" b="1"/>
+            </a:pPr>
+            <a:r>
+              <a:t>• Bᵥ then enters BOTH sides of the pipeline: the MILP constraint (labels) and the model input (conditioning) + the decoder feasibility mask</a:t>
+            </a:r>
+          </a:p>
+        </p:txBody>
+      </p:sp>
+    </p:spTree>
+  </p:cSld>
+  <p:clrMapOvr>
+    <a:masterClrMapping/>
+  </p:clrMapOvr>
+</p:sld>
+</file>
+
+<file path=ppt/slides/slide21.xml><?xml version="1.0" encoding="utf-8"?>
 <p:sld xmlns:a="http://schemas.openxmlformats.org/drawingml/2006/main" xmlns:p="http://schemas.openxmlformats.org/presentationml/2006/main" xmlns:r="http://schemas.openxmlformats.org/officeDocument/2006/relationships">
   <p:cSld>
     <p:spTree>
@@ -10248,7 +10718,7 @@
 </p:sld>
 </file>
 
-<file path=ppt/slides/slide21.xml><?xml version="1.0" encoding="utf-8"?>
+<file path=ppt/slides/slide22.xml><?xml version="1.0" encoding="utf-8"?>
 <p:sld xmlns:a="http://schemas.openxmlformats.org/drawingml/2006/main" xmlns:p="http://schemas.openxmlformats.org/presentationml/2006/main" xmlns:r="http://schemas.openxmlformats.org/officeDocument/2006/relationships">
   <p:cSld>
     <p:spTree>
@@ -10429,7 +10899,7 @@
 </p:sld>
 </file>
 
-<file path=ppt/slides/slide22.xml><?xml version="1.0" encoding="utf-8"?>
+<file path=ppt/slides/slide23.xml><?xml version="1.0" encoding="utf-8"?>
 <p:sld xmlns:a="http://schemas.openxmlformats.org/drawingml/2006/main" xmlns:p="http://schemas.openxmlformats.org/presentationml/2006/main" xmlns:r="http://schemas.openxmlformats.org/officeDocument/2006/relationships">
   <p:cSld>
     <p:spTree>
@@ -11583,7 +12053,7 @@
 </p:sld>
 </file>
 
-<file path=ppt/slides/slide23.xml><?xml version="1.0" encoding="utf-8"?>
+<file path=ppt/slides/slide24.xml><?xml version="1.0" encoding="utf-8"?>
 <p:sld xmlns:a="http://schemas.openxmlformats.org/drawingml/2006/main" xmlns:p="http://schemas.openxmlformats.org/presentationml/2006/main" xmlns:r="http://schemas.openxmlformats.org/officeDocument/2006/relationships">
   <p:cSld>
     <p:spTree>
@@ -12354,7 +12824,7 @@
 </p:sld>
 </file>
 
-<file path=ppt/slides/slide24.xml><?xml version="1.0" encoding="utf-8"?>
+<file path=ppt/slides/slide25.xml><?xml version="1.0" encoding="utf-8"?>
 <p:sld xmlns:a="http://schemas.openxmlformats.org/drawingml/2006/main" xmlns:p="http://schemas.openxmlformats.org/presentationml/2006/main" xmlns:r="http://schemas.openxmlformats.org/officeDocument/2006/relationships">
   <p:cSld>
     <p:spTree>
@@ -13180,7 +13650,7 @@
 </p:sld>
 </file>
 
-<file path=ppt/slides/slide25.xml><?xml version="1.0" encoding="utf-8"?>
+<file path=ppt/slides/slide26.xml><?xml version="1.0" encoding="utf-8"?>
 <p:sld xmlns:a="http://schemas.openxmlformats.org/drawingml/2006/main" xmlns:p="http://schemas.openxmlformats.org/presentationml/2006/main" xmlns:r="http://schemas.openxmlformats.org/officeDocument/2006/relationships">
   <p:cSld>
     <p:spTree>
@@ -14476,7 +14946,7 @@
 </p:sld>
 </file>
 
-<file path=ppt/slides/slide26.xml><?xml version="1.0" encoding="utf-8"?>
+<file path=ppt/slides/slide27.xml><?xml version="1.0" encoding="utf-8"?>
 <p:sld xmlns:a="http://schemas.openxmlformats.org/drawingml/2006/main" xmlns:p="http://schemas.openxmlformats.org/presentationml/2006/main" xmlns:r="http://schemas.openxmlformats.org/officeDocument/2006/relationships">
   <p:cSld>
     <p:spTree>
@@ -15748,179 +16218,6 @@
 </p:sld>
 </file>
 
-<file path=ppt/slides/slide27.xml><?xml version="1.0" encoding="utf-8"?>
-<p:sld xmlns:a="http://schemas.openxmlformats.org/drawingml/2006/main" xmlns:p="http://schemas.openxmlformats.org/presentationml/2006/main" xmlns:r="http://schemas.openxmlformats.org/officeDocument/2006/relationships">
-  <p:cSld>
-    <p:spTree>
-      <p:nvGrpSpPr>
-        <p:cNvPr id="1" name=""/>
-        <p:cNvGrpSpPr/>
-        <p:nvPr/>
-      </p:nvGrpSpPr>
-      <p:grpSpPr/>
-      <p:sp>
-        <p:nvSpPr>
-          <p:cNvPr id="7" name="文本占位符 6">
-            <a:extLst>
-              <a:ext uri="{FF2B5EF4-FFF2-40B4-BE49-F238E27FC236}">
-                <a16:creationId xmlns:a16="http://schemas.microsoft.com/office/drawing/2014/main" id="{33AE8DB3-4C29-0DE3-EB73-8D2BBFBB8CBF}"/>
-              </a:ext>
-            </a:extLst>
-          </p:cNvPr>
-          <p:cNvSpPr>
-            <a:spLocks noGrp="1"/>
-          </p:cNvSpPr>
-          <p:nvPr>
-            <p:ph type="body" sz="quarter" idx="11"/>
-          </p:nvPr>
-        </p:nvSpPr>
-        <p:spPr>
-          <a:xfrm>
-            <a:off x="336550" y="58738"/>
-            <a:ext cx="5759450" cy="622300"/>
-          </a:xfrm>
-        </p:spPr>
-        <p:txBody>
-          <a:bodyPr/>
-          <a:lstStyle/>
-          <a:p>
-            <a:r>
-              <a:rPr lang="en-US" altLang="zh-CN" dirty="0"/>
-              <a:t>Data</a:t>
-            </a:r>
-            <a:endParaRPr lang="zh-CN" altLang="en-US" dirty="0"/>
-          </a:p>
-        </p:txBody>
-      </p:sp>
-      <p:sp>
-        <p:nvSpPr>
-          <p:cNvPr id="203" name="文本占位符 5">
-            <a:extLst>
-              <a:ext uri="{FF2B5EF4-FFF2-40B4-BE49-F238E27FC236}">
-                <a16:creationId xmlns:a16="http://schemas.microsoft.com/office/drawing/2014/main" id="{A219F0BA-71F5-BA11-CCBD-9327897B98CC}"/>
-              </a:ext>
-            </a:extLst>
-          </p:cNvPr>
-          <p:cNvSpPr>
-            <a:spLocks noGrp="1"/>
-          </p:cNvSpPr>
-          <p:nvPr>
-            <p:ph type="body" sz="quarter" idx="10"/>
-          </p:nvPr>
-        </p:nvSpPr>
-        <p:spPr>
-          <a:xfrm>
-            <a:off x="0" y="820290"/>
-            <a:ext cx="5878224" cy="638175"/>
-          </a:xfrm>
-        </p:spPr>
-        <p:txBody>
-          <a:bodyPr/>
-          <a:lstStyle/>
-          <a:p>
-            <a:r>
-              <a:rPr lang="en-US" altLang="zh-CN" sz="2800" dirty="0"/>
-              <a:t>Label set</a:t>
-            </a:r>
-            <a:endParaRPr lang="zh-CN" altLang="en-US" sz="2800" dirty="0"/>
-          </a:p>
-        </p:txBody>
-      </p:sp>
-      <p:sp>
-        <p:nvSpPr>
-          <p:cNvPr id="204" name="TextBox 203"/>
-          <p:cNvSpPr txBox="1"/>
-          <p:nvPr/>
-        </p:nvSpPr>
-        <p:spPr>
-          <a:xfrm>
-            <a:off x="640080" y="1508760"/>
-            <a:ext cx="10881360" cy="914400"/>
-          </a:xfrm>
-          <a:prstGeom prst="rect">
-            <a:avLst/>
-          </a:prstGeom>
-          <a:noFill/>
-        </p:spPr>
-        <p:txBody>
-          <a:bodyPr wrap="square">
-            <a:spAutoFit/>
-          </a:bodyPr>
-          <a:lstStyle/>
-          <a:p>
-            <a:pPr>
-              <a:defRPr sz="1350" b="1"/>
-            </a:pPr>
-            <a:r>
-              <a:t>• 10 780 Gurobi labels · 0 errors · 0 solves hit the 60 s cap · 0.90 s mean per case (tight budgets prune the time-expanded graph → labelling ~30× faster than the full-horizon farm) · ~17 min on 15 workers, fully resumable</a:t>
-            </a:r>
-          </a:p>
-          <a:p>
-            <a:pPr>
-              <a:defRPr sz="1350" b="1"/>
-            </a:pPr>
-            <a:r>
-              <a:t>• Shards:</a:t>
-            </a:r>
-          </a:p>
-          <a:p>
-            <a:pPr>
-              <a:defRPr sz="1200" b="0"/>
-            </a:pPr>
-            <a:r>
-              <a:t>   – train 8 000 · same-distribution test 800</a:t>
-            </a:r>
-          </a:p>
-          <a:p>
-            <a:pPr>
-              <a:defRPr sz="1200" b="0"/>
-            </a:pPr>
-            <a:r>
-              <a:t>   – OD zero-shot 400 (4 gate pairs never trained) · fleet extrapolation 400 (V ∈ {5,8})</a:t>
-            </a:r>
-          </a:p>
-          <a:p>
-            <a:pPr>
-              <a:defRPr sz="1200" b="0"/>
-            </a:pPr>
-            <a:r>
-              <a:t>   – UNSEEN-budget interpolation 400 (ρ ∈ {1.25, 1.75}) · extrapolation 300 (ρ = 4.0)</a:t>
-            </a:r>
-          </a:p>
-          <a:p>
-            <a:pPr>
-              <a:defRPr sz="1200" b="0"/>
-            </a:pPr>
-            <a:r>
-              <a:t>   – response curve: 60 fixed instances × 8 ρ values, re-solved by Gurobi at every ρ</a:t>
-            </a:r>
-          </a:p>
-          <a:p>
-            <a:pPr>
-              <a:defRPr sz="1350" b="0"/>
-            </a:pPr>
-            <a:r>
-              <a:t>• Trained ρ anchors {1.0, 1.5, 2.0, 3.0}; the three held-out ρ values appear in NO training label</a:t>
-            </a:r>
-          </a:p>
-          <a:p>
-            <a:pPr>
-              <a:defRPr sz="1350" b="0"/>
-            </a:pPr>
-            <a:r>
-              <a:t>• Every label passes two checks at write time: flow-decomposed objective ≡ Gurobi ObjVal (1e-6) and every per-vehicle deadline re-validated</a:t>
-            </a:r>
-          </a:p>
-        </p:txBody>
-      </p:sp>
-    </p:spTree>
-  </p:cSld>
-  <p:clrMapOvr>
-    <a:masterClrMapping/>
-  </p:clrMapOvr>
-</p:sld>
-</file>
-
 <file path=ppt/slides/slide28.xml><?xml version="1.0" encoding="utf-8"?>
 <p:sld xmlns:a="http://schemas.openxmlformats.org/drawingml/2006/main" xmlns:p="http://schemas.openxmlformats.org/presentationml/2006/main" xmlns:r="http://schemas.openxmlformats.org/officeDocument/2006/relationships">
   <p:cSld>
@@ -15959,7 +16256,7 @@
           <a:p>
             <a:r>
               <a:rPr lang="en-US" altLang="zh-CN" dirty="0"/>
-              <a:t>Evaluation</a:t>
+              <a:t>Data</a:t>
             </a:r>
             <a:endParaRPr lang="zh-CN" altLang="en-US" dirty="0"/>
           </a:p>
@@ -15993,7 +16290,7 @@
           <a:p>
             <a:r>
               <a:rPr lang="en-US" altLang="zh-CN" sz="2800" dirty="0"/>
-              <a:t>Design</a:t>
+              <a:t>Label set</a:t>
             </a:r>
             <a:endParaRPr lang="zh-CN" altLang="en-US" sz="2800" dirty="0"/>
           </a:p>
@@ -16025,7 +16322,15 @@
               <a:defRPr sz="1350" b="1"/>
             </a:pPr>
             <a:r>
-              <a:t>• Five layers, 2 300 cases, none seen in training:</a:t>
+              <a:t>• 10 780 Gurobi labels · 0 errors · 0 solves hit the 60 s cap · 0.90 s mean per case (tight budgets prune the time-expanded graph → labelling ~30× faster than the full-horizon farm) · ~17 min on 15 workers, fully resumable</a:t>
+            </a:r>
+          </a:p>
+          <a:p>
+            <a:pPr>
+              <a:defRPr sz="1350" b="1"/>
+            </a:pPr>
+            <a:r>
+              <a:t>• Shards:</a:t>
             </a:r>
           </a:p>
           <a:p>
@@ -16033,7 +16338,7 @@
               <a:defRPr sz="1200" b="0"/>
             </a:pPr>
             <a:r>
-              <a:t>   – L1 same-distribution — 800 fresh cases (trained ODs, new δ / task mixes)</a:t>
+              <a:t>   – train 8 000 · same-distribution test 800</a:t>
             </a:r>
           </a:p>
           <a:p>
@@ -16041,7 +16346,7 @@
               <a:defRPr sz="1200" b="0"/>
             </a:pPr>
             <a:r>
-              <a:t>   – L2 OD ZERO-SHOT — 400 cases on 4 OD pairs never trained (G1→G5, G6→G2, G4→G8, G7→G3)</a:t>
+              <a:t>   – OD zero-shot 400 (4 gate pairs never trained) · fleet extrapolation 400 (V ∈ {5,8})</a:t>
             </a:r>
           </a:p>
           <a:p>
@@ -16049,7 +16354,7 @@
               <a:defRPr sz="1200" b="0"/>
             </a:pPr>
             <a:r>
-              <a:t>   – L3 fleet extrapolation — 400 cases with V ∈ {5, 8}, trained on {2,3,4,6}</a:t>
+              <a:t>   – UNSEEN-budget interpolation 400 (ρ ∈ {1.25, 1.75}) · extrapolation 300 (ρ = 4.0)</a:t>
             </a:r>
           </a:p>
           <a:p>
@@ -16057,23 +16362,7 @@
               <a:defRPr sz="1200" b="0"/>
             </a:pPr>
             <a:r>
-              <a:t>   – L4a UNSEEN budget, interpolation — 400 cases at ρ ∈ {1.25, 1.75}</a:t>
-            </a:r>
-          </a:p>
-          <a:p>
-            <a:pPr>
-              <a:defRPr sz="1200" b="0"/>
-            </a:pPr>
-            <a:r>
-              <a:t>   – L4b UNSEEN budget, extrapolation — 300 cases at ρ = 4.0, beyond the trained range</a:t>
-            </a:r>
-          </a:p>
-          <a:p>
-            <a:pPr>
-              <a:defRPr sz="1350" b="1"/>
-            </a:pPr>
-            <a:r>
-              <a:t>• Plus the RESPONSE CURVE: 60 fixed instances re-solved at every ρ by both Gurobi and the model — did it learn the budget as a continuous quantity or memorise four settings?</a:t>
+              <a:t>   – response curve: 60 fixed instances × 8 ρ values, re-solved by Gurobi at every ρ</a:t>
             </a:r>
           </a:p>
           <a:p>
@@ -16081,7 +16370,7 @@
               <a:defRPr sz="1350" b="0"/>
             </a:pPr>
             <a:r>
-              <a:t>• Metrics: feasibility rate · objective gap vs Gurobi (absolute + relative) · fraction matching or beating Gurobi · inference time · per-case CSV. 3 seeds, mean ± std</a:t>
+              <a:t>• Trained ρ anchors {1.0, 1.5, 2.0, 3.0}; the three held-out ρ values appear in NO training label</a:t>
             </a:r>
           </a:p>
           <a:p>
@@ -16089,7 +16378,7 @@
               <a:defRPr sz="1350" b="0"/>
             </a:pPr>
             <a:r>
-              <a:t>• Tuning used a validation slice of the training shard only; every reported number is from held-out shards</a:t>
+              <a:t>• Every label passes two checks at write time: flow-decomposed objective ≡ Gurobi ObjVal (1e-6) and every per-vehicle deadline re-validated</a:t>
             </a:r>
           </a:p>
         </p:txBody>
@@ -16140,7 +16429,7 @@
           <a:p>
             <a:r>
               <a:rPr lang="en-US" altLang="zh-CN" dirty="0"/>
-              <a:t>Results</a:t>
+              <a:t>Evaluation</a:t>
             </a:r>
             <a:endParaRPr lang="zh-CN" altLang="en-US" dirty="0"/>
           </a:p>
@@ -16174,45 +16463,21 @@
           <a:p>
             <a:r>
               <a:rPr lang="en-US" altLang="zh-CN" sz="2800" dirty="0"/>
-              <a:t>Five-layer exam</a:t>
+              <a:t>Design</a:t>
             </a:r>
             <a:endParaRPr lang="zh-CN" altLang="en-US" sz="2800" dirty="0"/>
           </a:p>
         </p:txBody>
       </p:sp>
-      <p:pic>
-        <p:nvPicPr>
-          <p:cNvPr id="204" name="Picture 203" descr="figS3_layers.png"/>
-          <p:cNvPicPr>
-            <a:picLocks noChangeAspect="1"/>
-          </p:cNvPicPr>
-          <p:nvPr/>
-        </p:nvPicPr>
-        <p:blipFill>
-          <a:blip r:embed="rId2"/>
-          <a:stretch>
-            <a:fillRect/>
-          </a:stretch>
-        </p:blipFill>
-        <p:spPr>
-          <a:xfrm>
-            <a:off x="1798167" y="1371600"/>
-            <a:ext cx="8595360" cy="4052617"/>
-          </a:xfrm>
-          <a:prstGeom prst="rect">
-            <a:avLst/>
-          </a:prstGeom>
-        </p:spPr>
-      </p:pic>
       <p:sp>
         <p:nvSpPr>
-          <p:cNvPr id="205" name="TextBox 204"/>
+          <p:cNvPr id="204" name="TextBox 203"/>
           <p:cNvSpPr txBox="1"/>
           <p:nvPr/>
         </p:nvSpPr>
         <p:spPr>
           <a:xfrm>
-            <a:off x="640080" y="5515656"/>
+            <a:off x="640080" y="1508760"/>
             <a:ext cx="10881360" cy="914400"/>
           </a:xfrm>
           <a:prstGeom prst="rect">
@@ -16227,18 +16492,74 @@
           <a:lstStyle/>
           <a:p>
             <a:pPr>
-              <a:defRPr sz="1250" b="0"/>
+              <a:defRPr sz="1350" b="1"/>
             </a:pPr>
             <a:r>
-              <a:t>• 3 seeds × 60 epochs · 2 300 held-out cases, 100 % feasible in every layer · 6–9 ms per case · 274/800 of L1 match or beat Gurobi</a:t>
+              <a:t>• Five layers, 2 300 cases, none seen in training:</a:t>
             </a:r>
           </a:p>
           <a:p>
             <a:pPr>
-              <a:defRPr sz="1250" b="1"/>
+              <a:defRPr sz="1200" b="0"/>
             </a:pPr>
             <a:r>
-              <a:t>• Unseen budgets (L4a, orange) cost about as much accuracy as an unseen fleet size — the budget generalises like the other conditioned attributes, not worse</a:t>
+              <a:t>   – L1 same-distribution — 800 fresh cases (trained ODs, new δ / task mixes)</a:t>
+            </a:r>
+          </a:p>
+          <a:p>
+            <a:pPr>
+              <a:defRPr sz="1200" b="0"/>
+            </a:pPr>
+            <a:r>
+              <a:t>   – L2 OD ZERO-SHOT — 400 cases on 4 OD pairs never trained (G1→G5, G6→G2, G4→G8, G7→G3)</a:t>
+            </a:r>
+          </a:p>
+          <a:p>
+            <a:pPr>
+              <a:defRPr sz="1200" b="0"/>
+            </a:pPr>
+            <a:r>
+              <a:t>   – L3 fleet extrapolation — 400 cases with V ∈ {5, 8}, trained on {2,3,4,6}</a:t>
+            </a:r>
+          </a:p>
+          <a:p>
+            <a:pPr>
+              <a:defRPr sz="1200" b="0"/>
+            </a:pPr>
+            <a:r>
+              <a:t>   – L4a UNSEEN budget, interpolation — 400 cases at ρ ∈ {1.25, 1.75}</a:t>
+            </a:r>
+          </a:p>
+          <a:p>
+            <a:pPr>
+              <a:defRPr sz="1200" b="0"/>
+            </a:pPr>
+            <a:r>
+              <a:t>   – L4b UNSEEN budget, extrapolation — 300 cases at ρ = 4.0, beyond the trained range</a:t>
+            </a:r>
+          </a:p>
+          <a:p>
+            <a:pPr>
+              <a:defRPr sz="1350" b="1"/>
+            </a:pPr>
+            <a:r>
+              <a:t>• Plus the RESPONSE CURVE: 60 fixed instances re-solved at every ρ by both Gurobi and the model — did it learn the budget as a continuous quantity or memorise four settings?</a:t>
+            </a:r>
+          </a:p>
+          <a:p>
+            <a:pPr>
+              <a:defRPr sz="1350" b="0"/>
+            </a:pPr>
+            <a:r>
+              <a:t>• Metrics: feasibility rate · objective gap vs Gurobi (absolute + relative) · fraction matching or beating Gurobi · inference time · per-case CSV. 3 seeds, mean ± std</a:t>
+            </a:r>
+          </a:p>
+          <a:p>
+            <a:pPr>
+              <a:defRPr sz="1350" b="0"/>
+            </a:pPr>
+            <a:r>
+              <a:t>• Tuning used a validation slice of the training shard only; every reported number is from held-out shards</a:t>
             </a:r>
           </a:p>
         </p:txBody>
@@ -16432,6 +16753,155 @@
           <a:p>
             <a:r>
               <a:rPr lang="en-US" altLang="zh-CN" sz="2800" dirty="0"/>
+              <a:t>Five-layer exam</a:t>
+            </a:r>
+            <a:endParaRPr lang="zh-CN" altLang="en-US" sz="2800" dirty="0"/>
+          </a:p>
+        </p:txBody>
+      </p:sp>
+      <p:pic>
+        <p:nvPicPr>
+          <p:cNvPr id="204" name="Picture 203" descr="figS3_layers.png"/>
+          <p:cNvPicPr>
+            <a:picLocks noChangeAspect="1"/>
+          </p:cNvPicPr>
+          <p:nvPr/>
+        </p:nvPicPr>
+        <p:blipFill>
+          <a:blip r:embed="rId2"/>
+          <a:stretch>
+            <a:fillRect/>
+          </a:stretch>
+        </p:blipFill>
+        <p:spPr>
+          <a:xfrm>
+            <a:off x="1798167" y="1371600"/>
+            <a:ext cx="8595360" cy="4052617"/>
+          </a:xfrm>
+          <a:prstGeom prst="rect">
+            <a:avLst/>
+          </a:prstGeom>
+        </p:spPr>
+      </p:pic>
+      <p:sp>
+        <p:nvSpPr>
+          <p:cNvPr id="205" name="TextBox 204"/>
+          <p:cNvSpPr txBox="1"/>
+          <p:nvPr/>
+        </p:nvSpPr>
+        <p:spPr>
+          <a:xfrm>
+            <a:off x="640080" y="5515656"/>
+            <a:ext cx="10881360" cy="914400"/>
+          </a:xfrm>
+          <a:prstGeom prst="rect">
+            <a:avLst/>
+          </a:prstGeom>
+          <a:noFill/>
+        </p:spPr>
+        <p:txBody>
+          <a:bodyPr wrap="square">
+            <a:spAutoFit/>
+          </a:bodyPr>
+          <a:lstStyle/>
+          <a:p>
+            <a:pPr>
+              <a:defRPr sz="1250" b="0"/>
+            </a:pPr>
+            <a:r>
+              <a:t>• 3 seeds × 60 epochs · 2 300 held-out cases, 100 % feasible in every layer · 6–9 ms per case · 274/800 of L1 match or beat Gurobi</a:t>
+            </a:r>
+          </a:p>
+          <a:p>
+            <a:pPr>
+              <a:defRPr sz="1250" b="1"/>
+            </a:pPr>
+            <a:r>
+              <a:t>• Unseen budgets (L4a, orange) cost about as much accuracy as an unseen fleet size — the budget generalises like the other conditioned attributes, not worse</a:t>
+            </a:r>
+          </a:p>
+        </p:txBody>
+      </p:sp>
+    </p:spTree>
+  </p:cSld>
+  <p:clrMapOvr>
+    <a:masterClrMapping/>
+  </p:clrMapOvr>
+</p:sld>
+</file>
+
+<file path=ppt/slides/slide31.xml><?xml version="1.0" encoding="utf-8"?>
+<p:sld xmlns:a="http://schemas.openxmlformats.org/drawingml/2006/main" xmlns:p="http://schemas.openxmlformats.org/presentationml/2006/main" xmlns:r="http://schemas.openxmlformats.org/officeDocument/2006/relationships">
+  <p:cSld>
+    <p:spTree>
+      <p:nvGrpSpPr>
+        <p:cNvPr id="1" name=""/>
+        <p:cNvGrpSpPr/>
+        <p:nvPr/>
+      </p:nvGrpSpPr>
+      <p:grpSpPr/>
+      <p:sp>
+        <p:nvSpPr>
+          <p:cNvPr id="7" name="文本占位符 6">
+            <a:extLst>
+              <a:ext uri="{FF2B5EF4-FFF2-40B4-BE49-F238E27FC236}">
+                <a16:creationId xmlns:a16="http://schemas.microsoft.com/office/drawing/2014/main" id="{33AE8DB3-4C29-0DE3-EB73-8D2BBFBB8CBF}"/>
+              </a:ext>
+            </a:extLst>
+          </p:cNvPr>
+          <p:cNvSpPr>
+            <a:spLocks noGrp="1"/>
+          </p:cNvSpPr>
+          <p:nvPr>
+            <p:ph type="body" sz="quarter" idx="11"/>
+          </p:nvPr>
+        </p:nvSpPr>
+        <p:spPr>
+          <a:xfrm>
+            <a:off x="336550" y="58738"/>
+            <a:ext cx="5759450" cy="622300"/>
+          </a:xfrm>
+        </p:spPr>
+        <p:txBody>
+          <a:bodyPr/>
+          <a:lstStyle/>
+          <a:p>
+            <a:r>
+              <a:rPr lang="en-US" altLang="zh-CN" dirty="0"/>
+              <a:t>Results</a:t>
+            </a:r>
+            <a:endParaRPr lang="zh-CN" altLang="en-US" dirty="0"/>
+          </a:p>
+        </p:txBody>
+      </p:sp>
+      <p:sp>
+        <p:nvSpPr>
+          <p:cNvPr id="203" name="文本占位符 5">
+            <a:extLst>
+              <a:ext uri="{FF2B5EF4-FFF2-40B4-BE49-F238E27FC236}">
+                <a16:creationId xmlns:a16="http://schemas.microsoft.com/office/drawing/2014/main" id="{A219F0BA-71F5-BA11-CCBD-9327897B98CC}"/>
+              </a:ext>
+            </a:extLst>
+          </p:cNvPr>
+          <p:cNvSpPr>
+            <a:spLocks noGrp="1"/>
+          </p:cNvSpPr>
+          <p:nvPr>
+            <p:ph type="body" sz="quarter" idx="10"/>
+          </p:nvPr>
+        </p:nvSpPr>
+        <p:spPr>
+          <a:xfrm>
+            <a:off x="0" y="820290"/>
+            <a:ext cx="5878224" cy="638175"/>
+          </a:xfrm>
+        </p:spPr>
+        <p:txBody>
+          <a:bodyPr/>
+          <a:lstStyle/>
+          <a:p>
+            <a:r>
+              <a:rPr lang="en-US" altLang="zh-CN" sz="2800" dirty="0"/>
               <a:t>Budget response curve</a:t>
             </a:r>
             <a:endParaRPr lang="zh-CN" altLang="en-US" sz="2800" dirty="0"/>
@@ -16501,7 +16971,7 @@
 </p:sld>
 </file>
 
-<file path=ppt/slides/slide31.xml><?xml version="1.0" encoding="utf-8"?>
+<file path=ppt/slides/slide32.xml><?xml version="1.0" encoding="utf-8"?>
 <p:sld xmlns:a="http://schemas.openxmlformats.org/drawingml/2006/main" xmlns:p="http://schemas.openxmlformats.org/presentationml/2006/main" xmlns:r="http://schemas.openxmlformats.org/officeDocument/2006/relationships">
   <p:cSld>
     <p:spTree>

</xml_diff>

<commit_message>
deck r1 (YIL-125): TD travel-time animation + delta operating-day figure; slide-4 caption states the (t0=0, delta=0) slice and link-id semantics; 24 slides
- build_anim.py: figA_td_travel.gif (t0 sweep 0..160, links coloured by entry
  cost + 8x8 duration matrix, * = arrival past H) and figA_delta_day.png
  (sampled day's per-directed-link delta + increment matrix vs delta=0)
- new slides 5 'Time-dependence' and 6 'Day-to-day: delta'; report stage
  now runs build_anim.py

Co-Authored-By: Claude Fable 5 <noreply@anthropic.com>
</commit_message>
<xml_diff>
--- a/experiments/20260804-budget-conditioning/ppt/sensing_routing_method_and_results.pptx
+++ b/experiments/20260804-budget-conditioning/ppt/sensing_routing_method_and_results.pptx
@@ -30,6 +30,8 @@
     <p:sldId id="343" r:id="rId37"/>
     <p:sldId id="344" r:id="rId38"/>
     <p:sldId id="345" r:id="rId39"/>
+    <p:sldId id="346" r:id="rId40"/>
+    <p:sldId id="347" r:id="rId41"/>
   </p:sldIdLst>
   <p:sldSz cx="12192000" cy="6858000"/>
   <p:notesSz cx="6858000" cy="9144000"/>
@@ -6609,8 +6611,8 @@
         </p:nvSpPr>
         <p:spPr>
           <a:xfrm>
-            <a:off x="640080" y="5535931"/>
-            <a:ext cx="10881360" cy="914400"/>
+            <a:off x="1874519" y="5535931"/>
+            <a:ext cx="9692640" cy="914400"/>
           </a:xfrm>
           <a:prstGeom prst="rect">
             <a:avLst/>
@@ -6624,15 +6626,23 @@
           <a:lstStyle/>
           <a:p>
             <a:pPr>
-              <a:defRPr sz="1250" b="0"/>
+              <a:defRPr sz="1150" b="0"/>
             </a:pPr>
             <a:r>
-              <a:t>• Fixed bidirectional 4×4: 80 directed links, no U-turns · 8 gates (4 corners + 4 edge midpoints) · all 56 ordered OD pairs feasible (heatmap) · horizon H = 338</a:t>
+              <a:t>• Fixed bidirectional 4×4: 80 directed links, no U-turns · 8 gates (4 corners + 4 edge midpoints) · all 56 ordered OD pairs feasible · horizon H = 338. Link numbers = directed link ids 1–80 (E 1–20 · W 21–40 · S 41–60 · N 61–80) — the model's token ids; base(i) = min(id, reverse id) sets each street's base cost, so E/W streets are structurally faster than N/S</a:t>
             </a:r>
           </a:p>
           <a:p>
             <a:pPr>
-              <a:defRPr sz="1250" b="1"/>
+              <a:defRPr sz="1150" b="1"/>
+            </a:pPr>
+            <a:r>
+              <a:t>• Heatmap = earliest arrival departing t₀ = 0 on the δ = 0 day — ONE slice of a time-varying quantity (next two slides)</a:t>
+            </a:r>
+          </a:p>
+          <a:p>
+            <a:pPr>
+              <a:defRPr sz="1150" b="0"/>
             </a:pPr>
             <a:r>
               <a:t>• The network and the OD set are FIXED; what varies per case is δ, V, and each vehicle's (o, d, t₀, B)</a:t>
@@ -6649,6 +6659,320 @@
 </file>
 
 <file path=ppt/slides/slide15.xml><?xml version="1.0" encoding="utf-8"?>
+<p:sld xmlns:a="http://schemas.openxmlformats.org/drawingml/2006/main" xmlns:p="http://schemas.openxmlformats.org/presentationml/2006/main" xmlns:r="http://schemas.openxmlformats.org/officeDocument/2006/relationships">
+  <p:cSld>
+    <p:spTree>
+      <p:nvGrpSpPr>
+        <p:cNvPr id="1" name=""/>
+        <p:cNvGrpSpPr/>
+        <p:nvPr/>
+      </p:nvGrpSpPr>
+      <p:grpSpPr/>
+      <p:sp>
+        <p:nvSpPr>
+          <p:cNvPr id="7" name="文本占位符 6">
+            <a:extLst>
+              <a:ext uri="{FF2B5EF4-FFF2-40B4-BE49-F238E27FC236}">
+                <a16:creationId xmlns:a16="http://schemas.microsoft.com/office/drawing/2014/main" id="{33AE8DB3-4C29-0DE3-EB73-8D2BBFBB8CBF}"/>
+              </a:ext>
+            </a:extLst>
+          </p:cNvPr>
+          <p:cNvSpPr>
+            <a:spLocks noGrp="1"/>
+          </p:cNvSpPr>
+          <p:nvPr>
+            <p:ph type="body" sz="quarter" idx="11"/>
+          </p:nvPr>
+        </p:nvSpPr>
+        <p:spPr>
+          <a:xfrm>
+            <a:off x="336550" y="58738"/>
+            <a:ext cx="5759450" cy="622300"/>
+          </a:xfrm>
+        </p:spPr>
+        <p:txBody>
+          <a:bodyPr/>
+          <a:lstStyle/>
+          <a:p>
+            <a:r>
+              <a:rPr lang="en-US" altLang="zh-CN" dirty="0"/>
+              <a:t>The problem</a:t>
+            </a:r>
+            <a:endParaRPr lang="zh-CN" altLang="en-US" dirty="0"/>
+          </a:p>
+        </p:txBody>
+      </p:sp>
+      <p:sp>
+        <p:nvSpPr>
+          <p:cNvPr id="203" name="文本占位符 5">
+            <a:extLst>
+              <a:ext uri="{FF2B5EF4-FFF2-40B4-BE49-F238E27FC236}">
+                <a16:creationId xmlns:a16="http://schemas.microsoft.com/office/drawing/2014/main" id="{A219F0BA-71F5-BA11-CCBD-9327897B98CC}"/>
+              </a:ext>
+            </a:extLst>
+          </p:cNvPr>
+          <p:cNvSpPr>
+            <a:spLocks noGrp="1"/>
+          </p:cNvSpPr>
+          <p:nvPr>
+            <p:ph type="body" sz="quarter" idx="10"/>
+          </p:nvPr>
+        </p:nvSpPr>
+        <p:spPr>
+          <a:xfrm>
+            <a:off x="0" y="820290"/>
+            <a:ext cx="5878224" cy="638175"/>
+          </a:xfrm>
+        </p:spPr>
+        <p:txBody>
+          <a:bodyPr/>
+          <a:lstStyle/>
+          <a:p>
+            <a:r>
+              <a:rPr lang="en-US" altLang="zh-CN" sz="2800" dirty="0"/>
+              <a:t>Time-dependence</a:t>
+            </a:r>
+            <a:endParaRPr lang="zh-CN" altLang="en-US" sz="2800" dirty="0"/>
+          </a:p>
+        </p:txBody>
+      </p:sp>
+      <p:pic>
+        <p:nvPicPr>
+          <p:cNvPr id="204" name="Picture 203" descr="figA_td_travel.gif"/>
+          <p:cNvPicPr>
+            <a:picLocks noChangeAspect="1"/>
+          </p:cNvPicPr>
+          <p:nvPr/>
+        </p:nvPicPr>
+        <p:blipFill>
+          <a:blip r:embed="rId2"/>
+          <a:stretch>
+            <a:fillRect/>
+          </a:stretch>
+        </p:blipFill>
+        <p:spPr>
+          <a:xfrm>
+            <a:off x="1615287" y="1325880"/>
+            <a:ext cx="8961120" cy="3733800"/>
+          </a:xfrm>
+          <a:prstGeom prst="rect">
+            <a:avLst/>
+          </a:prstGeom>
+        </p:spPr>
+      </p:pic>
+      <p:sp>
+        <p:nvSpPr>
+          <p:cNvPr id="205" name="TextBox 204"/>
+          <p:cNvSpPr txBox="1"/>
+          <p:nvPr/>
+        </p:nvSpPr>
+        <p:spPr>
+          <a:xfrm>
+            <a:off x="1874519" y="5257800"/>
+            <a:ext cx="9692640" cy="914400"/>
+          </a:xfrm>
+          <a:prstGeom prst="rect">
+            <a:avLst/>
+          </a:prstGeom>
+          <a:noFill/>
+        </p:spPr>
+        <p:txBody>
+          <a:bodyPr wrap="square">
+            <a:spAutoFit/>
+          </a:bodyPr>
+          <a:lstStyle/>
+          <a:p>
+            <a:pPr>
+              <a:defRPr sz="1150" b="1"/>
+            </a:pPr>
+            <a:r>
+              <a:t>• The previous slide's heatmap is ONE frame of this animation: departing t₀ = 0 on the δ = 0 day. Re-running TD-Dijkstra at later departures: G1→G2 takes 2 / 47 / 92 and G7→G3 takes 159 / 555 / 955 at t₀ = 0 / 80 / 160 (* = would arrive after H = 338)</a:t>
+            </a:r>
+          </a:p>
+          <a:p>
+            <a:pPr>
+              <a:defRPr sz="1150" b="0"/>
+            </a:pPr>
+            <a:r>
+              <a:t>• Why: entry cost c(i,t) = (base(i)+t)//4 + 1 + δᵢ rises with t (FIFO staircase, +1 every 4 steps) — so earliest arrival depends on departure time, and the pipeline always uses the right one: Bᵥ at the vehicle's own t₀ᵥ, the decoder mask at the current decode time</a:t>
+            </a:r>
+          </a:p>
+          <a:p>
+            <a:pPr>
+              <a:defRPr sz="1150" b="0"/>
+            </a:pPr>
+            <a:r>
+              <a:t>• Animated GIF — plays in slideshow mode; in print this page shows the t₀ = 0 frame</a:t>
+            </a:r>
+          </a:p>
+        </p:txBody>
+      </p:sp>
+    </p:spTree>
+  </p:cSld>
+  <p:clrMapOvr>
+    <a:masterClrMapping/>
+  </p:clrMapOvr>
+</p:sld>
+</file>
+
+<file path=ppt/slides/slide16.xml><?xml version="1.0" encoding="utf-8"?>
+<p:sld xmlns:a="http://schemas.openxmlformats.org/drawingml/2006/main" xmlns:p="http://schemas.openxmlformats.org/presentationml/2006/main" xmlns:r="http://schemas.openxmlformats.org/officeDocument/2006/relationships">
+  <p:cSld>
+    <p:spTree>
+      <p:nvGrpSpPr>
+        <p:cNvPr id="1" name=""/>
+        <p:cNvGrpSpPr/>
+        <p:nvPr/>
+      </p:nvGrpSpPr>
+      <p:grpSpPr/>
+      <p:sp>
+        <p:nvSpPr>
+          <p:cNvPr id="7" name="文本占位符 6">
+            <a:extLst>
+              <a:ext uri="{FF2B5EF4-FFF2-40B4-BE49-F238E27FC236}">
+                <a16:creationId xmlns:a16="http://schemas.microsoft.com/office/drawing/2014/main" id="{33AE8DB3-4C29-0DE3-EB73-8D2BBFBB8CBF}"/>
+              </a:ext>
+            </a:extLst>
+          </p:cNvPr>
+          <p:cNvSpPr>
+            <a:spLocks noGrp="1"/>
+          </p:cNvSpPr>
+          <p:nvPr>
+            <p:ph type="body" sz="quarter" idx="11"/>
+          </p:nvPr>
+        </p:nvSpPr>
+        <p:spPr>
+          <a:xfrm>
+            <a:off x="336550" y="58738"/>
+            <a:ext cx="5759450" cy="622300"/>
+          </a:xfrm>
+        </p:spPr>
+        <p:txBody>
+          <a:bodyPr/>
+          <a:lstStyle/>
+          <a:p>
+            <a:r>
+              <a:rPr lang="en-US" altLang="zh-CN" dirty="0"/>
+              <a:t>The problem</a:t>
+            </a:r>
+            <a:endParaRPr lang="zh-CN" altLang="en-US" dirty="0"/>
+          </a:p>
+        </p:txBody>
+      </p:sp>
+      <p:sp>
+        <p:nvSpPr>
+          <p:cNvPr id="203" name="文本占位符 5">
+            <a:extLst>
+              <a:ext uri="{FF2B5EF4-FFF2-40B4-BE49-F238E27FC236}">
+                <a16:creationId xmlns:a16="http://schemas.microsoft.com/office/drawing/2014/main" id="{A219F0BA-71F5-BA11-CCBD-9327897B98CC}"/>
+              </a:ext>
+            </a:extLst>
+          </p:cNvPr>
+          <p:cNvSpPr>
+            <a:spLocks noGrp="1"/>
+          </p:cNvSpPr>
+          <p:nvPr>
+            <p:ph type="body" sz="quarter" idx="10"/>
+          </p:nvPr>
+        </p:nvSpPr>
+        <p:spPr>
+          <a:xfrm>
+            <a:off x="0" y="820290"/>
+            <a:ext cx="5878224" cy="638175"/>
+          </a:xfrm>
+        </p:spPr>
+        <p:txBody>
+          <a:bodyPr/>
+          <a:lstStyle/>
+          <a:p>
+            <a:r>
+              <a:rPr lang="en-US" altLang="zh-CN" sz="2800" dirty="0"/>
+              <a:t>Day-to-day: δ</a:t>
+            </a:r>
+            <a:endParaRPr lang="zh-CN" altLang="en-US" sz="2800" dirty="0"/>
+          </a:p>
+        </p:txBody>
+      </p:sp>
+      <p:pic>
+        <p:nvPicPr>
+          <p:cNvPr id="204" name="Picture 203" descr="figA_delta_day.png"/>
+          <p:cNvPicPr>
+            <a:picLocks noChangeAspect="1"/>
+          </p:cNvPicPr>
+          <p:nvPr/>
+        </p:nvPicPr>
+        <p:blipFill>
+          <a:blip r:embed="rId2"/>
+          <a:stretch>
+            <a:fillRect/>
+          </a:stretch>
+        </p:blipFill>
+        <p:spPr>
+          <a:xfrm>
+            <a:off x="1706727" y="1371600"/>
+            <a:ext cx="8778240" cy="3488788"/>
+          </a:xfrm>
+          <a:prstGeom prst="rect">
+            <a:avLst/>
+          </a:prstGeom>
+        </p:spPr>
+      </p:pic>
+      <p:sp>
+        <p:nvSpPr>
+          <p:cNvPr id="205" name="TextBox 204"/>
+          <p:cNvSpPr txBox="1"/>
+          <p:nvPr/>
+        </p:nvSpPr>
+        <p:spPr>
+          <a:xfrm>
+            <a:off x="1874519" y="5074920"/>
+            <a:ext cx="9692640" cy="914400"/>
+          </a:xfrm>
+          <a:prstGeom prst="rect">
+            <a:avLst/>
+          </a:prstGeom>
+          <a:noFill/>
+        </p:spPr>
+        <p:txBody>
+          <a:bodyPr wrap="square">
+            <a:spAutoFit/>
+          </a:bodyPr>
+          <a:lstStyle/>
+          <a:p>
+            <a:pPr>
+              <a:defRPr sz="1150" b="1"/>
+            </a:pPr>
+            <a:r>
+              <a:t>• δ ∈ {0,1}⁸⁰: one bit per DIRECTED link, drawn i.i.d. Bernoulli(½) per operating day (the farm's sampler); δᵢ = 1 adds +1 to EVERY traversal of link i that day</a:t>
+            </a:r>
+          </a:p>
+          <a:p>
+            <a:pPr>
+              <a:defRPr sz="1150" b="0"/>
+            </a:pPr>
+            <a:r>
+              <a:t>• An instance property shared by the whole fleet — not a vehicle attribute; the two directions of one street can differ (left: one-way congestion is visible)</a:t>
+            </a:r>
+          </a:p>
+          <a:p>
+            <a:pPr>
+              <a:defRPr sz="1150" b="0"/>
+            </a:pPr>
+            <a:r>
+              <a:t>• Effect at t₀ = 0 (right): this sampled day adds +0 … +19 steps across the 56 ODs. The model sees δ in the encoder: each link token = link_emb(i) + Proj(δᵢ) (encoder slide)</a:t>
+            </a:r>
+          </a:p>
+        </p:txBody>
+      </p:sp>
+    </p:spTree>
+  </p:cSld>
+  <p:clrMapOvr>
+    <a:masterClrMapping/>
+  </p:clrMapOvr>
+</p:sld>
+</file>
+
+<file path=ppt/slides/slide17.xml><?xml version="1.0" encoding="utf-8"?>
 <p:sld xmlns:a="http://schemas.openxmlformats.org/drawingml/2006/main" xmlns:p="http://schemas.openxmlformats.org/presentationml/2006/main" xmlns:r="http://schemas.openxmlformats.org/officeDocument/2006/relationships">
   <p:cSld>
     <p:spTree>
@@ -7217,7 +7541,7 @@
 </p:sld>
 </file>
 
-<file path=ppt/slides/slide16.xml><?xml version="1.0" encoding="utf-8"?>
+<file path=ppt/slides/slide18.xml><?xml version="1.0" encoding="utf-8"?>
 <p:sld xmlns:a="http://schemas.openxmlformats.org/drawingml/2006/main" xmlns:p="http://schemas.openxmlformats.org/presentationml/2006/main" xmlns:r="http://schemas.openxmlformats.org/officeDocument/2006/relationships">
   <p:cSld>
     <p:spTree>
@@ -7562,7 +7886,7 @@
 </p:sld>
 </file>
 
-<file path=ppt/slides/slide17.xml><?xml version="1.0" encoding="utf-8"?>
+<file path=ppt/slides/slide19.xml><?xml version="1.0" encoding="utf-8"?>
 <p:sld xmlns:a="http://schemas.openxmlformats.org/drawingml/2006/main" xmlns:p="http://schemas.openxmlformats.org/presentationml/2006/main" xmlns:r="http://schemas.openxmlformats.org/officeDocument/2006/relationships">
   <p:cSld>
     <p:spTree>
@@ -7832,616 +8156,6 @@
             </a:pPr>
             <a:r>
               <a:t>• That is change (a): keep α fixed (0.3/0.7, roam regime), move the control to the constraint — the per-vehicle budget Bᵥ. Next slide: both claims measured on one instance</a:t>
-            </a:r>
-          </a:p>
-        </p:txBody>
-      </p:sp>
-    </p:spTree>
-  </p:cSld>
-  <p:clrMapOvr>
-    <a:masterClrMapping/>
-  </p:clrMapOvr>
-</p:sld>
-</file>
-
-<file path=ppt/slides/slide18.xml><?xml version="1.0" encoding="utf-8"?>
-<p:sld xmlns:a="http://schemas.openxmlformats.org/drawingml/2006/main" xmlns:p="http://schemas.openxmlformats.org/presentationml/2006/main" xmlns:r="http://schemas.openxmlformats.org/officeDocument/2006/relationships">
-  <p:cSld>
-    <p:spTree>
-      <p:nvGrpSpPr>
-        <p:cNvPr id="1" name=""/>
-        <p:cNvGrpSpPr/>
-        <p:nvPr/>
-      </p:nvGrpSpPr>
-      <p:grpSpPr/>
-      <p:sp>
-        <p:nvSpPr>
-          <p:cNvPr id="7" name="文本占位符 6">
-            <a:extLst>
-              <a:ext uri="{FF2B5EF4-FFF2-40B4-BE49-F238E27FC236}">
-                <a16:creationId xmlns:a16="http://schemas.microsoft.com/office/drawing/2014/main" id="{33AE8DB3-4C29-0DE3-EB73-8D2BBFBB8CBF}"/>
-              </a:ext>
-            </a:extLst>
-          </p:cNvPr>
-          <p:cNvSpPr>
-            <a:spLocks noGrp="1"/>
-          </p:cNvSpPr>
-          <p:nvPr>
-            <p:ph type="body" sz="quarter" idx="11"/>
-          </p:nvPr>
-        </p:nvSpPr>
-        <p:spPr>
-          <a:xfrm>
-            <a:off x="336550" y="58738"/>
-            <a:ext cx="5759450" cy="622300"/>
-          </a:xfrm>
-        </p:spPr>
-        <p:txBody>
-          <a:bodyPr/>
-          <a:lstStyle/>
-          <a:p>
-            <a:r>
-              <a:rPr lang="en-US" altLang="zh-CN" dirty="0"/>
-              <a:t>Change (a) — objective</a:t>
-            </a:r>
-            <a:endParaRPr lang="zh-CN" altLang="en-US" dirty="0"/>
-          </a:p>
-        </p:txBody>
-      </p:sp>
-      <p:sp>
-        <p:nvSpPr>
-          <p:cNvPr id="203" name="文本占位符 5">
-            <a:extLst>
-              <a:ext uri="{FF2B5EF4-FFF2-40B4-BE49-F238E27FC236}">
-                <a16:creationId xmlns:a16="http://schemas.microsoft.com/office/drawing/2014/main" id="{A219F0BA-71F5-BA11-CCBD-9327897B98CC}"/>
-              </a:ext>
-            </a:extLst>
-          </p:cNvPr>
-          <p:cNvSpPr>
-            <a:spLocks noGrp="1"/>
-          </p:cNvSpPr>
-          <p:nvPr>
-            <p:ph type="body" sz="quarter" idx="10"/>
-          </p:nvPr>
-        </p:nvSpPr>
-        <p:spPr>
-          <a:xfrm>
-            <a:off x="0" y="820290"/>
-            <a:ext cx="5878224" cy="638175"/>
-          </a:xfrm>
-        </p:spPr>
-        <p:txBody>
-          <a:bodyPr/>
-          <a:lstStyle/>
-          <a:p>
-            <a:r>
-              <a:rPr lang="en-US" altLang="zh-CN" sz="2800" dirty="0"/>
-              <a:t>Switch vs dial — measured</a:t>
-            </a:r>
-            <a:endParaRPr lang="zh-CN" altLang="en-US" sz="2800" dirty="0"/>
-          </a:p>
-        </p:txBody>
-      </p:sp>
-      <p:pic>
-        <p:nvPicPr>
-          <p:cNvPr id="204" name="Picture 203" descr="figS1_knob_vs_switch.png"/>
-          <p:cNvPicPr>
-            <a:picLocks noChangeAspect="1"/>
-          </p:cNvPicPr>
-          <p:nvPr/>
-        </p:nvPicPr>
-        <p:blipFill>
-          <a:blip r:embed="rId2"/>
-          <a:stretch>
-            <a:fillRect/>
-          </a:stretch>
-        </p:blipFill>
-        <p:spPr>
-          <a:xfrm>
-            <a:off x="792327" y="1371600"/>
-            <a:ext cx="10607040" cy="4060090"/>
-          </a:xfrm>
-          <a:prstGeom prst="rect">
-            <a:avLst/>
-          </a:prstGeom>
-        </p:spPr>
-      </p:pic>
-      <p:sp>
-        <p:nvSpPr>
-          <p:cNvPr id="205" name="TextBox 204"/>
-          <p:cNvSpPr txBox="1"/>
-          <p:nvPr/>
-        </p:nvSpPr>
-        <p:spPr>
-          <a:xfrm>
-            <a:off x="640080" y="5523129"/>
-            <a:ext cx="10881360" cy="914400"/>
-          </a:xfrm>
-          <a:prstGeom prst="rect">
-            <a:avLst/>
-          </a:prstGeom>
-          <a:noFill/>
-        </p:spPr>
-        <p:txBody>
-          <a:bodyPr wrap="square">
-            <a:spAutoFit/>
-          </a:bodyPr>
-          <a:lstStyle/>
-          <a:p>
-            <a:pPr>
-              <a:defRPr sz="1250" b="0"/>
-            </a:pPr>
-            <a:r>
-              <a:t>• One fixed instance, one MILP, one solver, MIPGap 0.5 %. LEFT: 13 values of α₂ with the budget fixed at H → 2 distinct solutions (α₂ = 0.10–0.48 identical link-for-link). RIGHT: α frozen at 0.3/0.7, per-vehicle budget swept → 10 distinct, monotone solutions</a:t>
-            </a:r>
-          </a:p>
-        </p:txBody>
-      </p:sp>
-    </p:spTree>
-  </p:cSld>
-  <p:clrMapOvr>
-    <a:masterClrMapping/>
-  </p:clrMapOvr>
-</p:sld>
-</file>
-
-<file path=ppt/slides/slide19.xml><?xml version="1.0" encoding="utf-8"?>
-<p:sld xmlns:a="http://schemas.openxmlformats.org/drawingml/2006/main" xmlns:p="http://schemas.openxmlformats.org/presentationml/2006/main" xmlns:r="http://schemas.openxmlformats.org/officeDocument/2006/relationships">
-  <p:cSld>
-    <p:spTree>
-      <p:nvGrpSpPr>
-        <p:cNvPr id="1" name=""/>
-        <p:cNvGrpSpPr/>
-        <p:nvPr/>
-      </p:nvGrpSpPr>
-      <p:grpSpPr/>
-      <p:sp>
-        <p:nvSpPr>
-          <p:cNvPr id="7" name="文本占位符 6">
-            <a:extLst>
-              <a:ext uri="{FF2B5EF4-FFF2-40B4-BE49-F238E27FC236}">
-                <a16:creationId xmlns:a16="http://schemas.microsoft.com/office/drawing/2014/main" id="{33AE8DB3-4C29-0DE3-EB73-8D2BBFBB8CBF}"/>
-              </a:ext>
-            </a:extLst>
-          </p:cNvPr>
-          <p:cNvSpPr>
-            <a:spLocks noGrp="1"/>
-          </p:cNvSpPr>
-          <p:nvPr>
-            <p:ph type="body" sz="quarter" idx="11"/>
-          </p:nvPr>
-        </p:nvSpPr>
-        <p:spPr>
-          <a:xfrm>
-            <a:off x="336550" y="58738"/>
-            <a:ext cx="5759450" cy="622300"/>
-          </a:xfrm>
-        </p:spPr>
-        <p:txBody>
-          <a:bodyPr/>
-          <a:lstStyle/>
-          <a:p>
-            <a:r>
-              <a:rPr lang="en-US" altLang="zh-CN" dirty="0"/>
-              <a:t>Change (a) — objective</a:t>
-            </a:r>
-            <a:endParaRPr lang="zh-CN" altLang="en-US" dirty="0"/>
-          </a:p>
-        </p:txBody>
-      </p:sp>
-      <p:sp>
-        <p:nvSpPr>
-          <p:cNvPr id="203" name="文本占位符 5">
-            <a:extLst>
-              <a:ext uri="{FF2B5EF4-FFF2-40B4-BE49-F238E27FC236}">
-                <a16:creationId xmlns:a16="http://schemas.microsoft.com/office/drawing/2014/main" id="{A219F0BA-71F5-BA11-CCBD-9327897B98CC}"/>
-              </a:ext>
-            </a:extLst>
-          </p:cNvPr>
-          <p:cNvSpPr>
-            <a:spLocks noGrp="1"/>
-          </p:cNvSpPr>
-          <p:nvPr>
-            <p:ph type="body" sz="quarter" idx="10"/>
-          </p:nvPr>
-        </p:nvSpPr>
-        <p:spPr>
-          <a:xfrm>
-            <a:off x="0" y="820290"/>
-            <a:ext cx="5878224" cy="638175"/>
-          </a:xfrm>
-        </p:spPr>
-        <p:txBody>
-          <a:bodyPr/>
-          <a:lstStyle/>
-          <a:p>
-            <a:r>
-              <a:rPr lang="en-US" altLang="zh-CN" sz="2800" dirty="0"/>
-              <a:t>Step 0: earliest arrival</a:t>
-            </a:r>
-            <a:endParaRPr lang="zh-CN" altLang="en-US" sz="2800" dirty="0"/>
-          </a:p>
-        </p:txBody>
-      </p:sp>
-      <p:sp>
-        <p:nvSpPr>
-          <p:cNvPr id="204" name="TextBox 203"/>
-          <p:cNvSpPr txBox="1"/>
-          <p:nvPr/>
-        </p:nvSpPr>
-        <p:spPr>
-          <a:xfrm>
-            <a:off x="685800" y="1353312"/>
-            <a:ext cx="10881360" cy="274320"/>
-          </a:xfrm>
-          <a:prstGeom prst="rect">
-            <a:avLst/>
-          </a:prstGeom>
-          <a:noFill/>
-        </p:spPr>
-        <p:txBody>
-          <a:bodyPr wrap="square">
-            <a:spAutoFit/>
-          </a:bodyPr>
-          <a:lstStyle/>
-          <a:p>
-            <a:pPr algn="l">
-              <a:defRPr sz="1250" b="1">
-                <a:solidFill>
-                  <a:srgbClr val="52514E"/>
-                </a:solidFill>
-              </a:defRPr>
-            </a:pPr>
-            <a:r>
-              <a:t>Before any budget can be set, we must know the fastest this vehicle could possibly make its trip TODAY — earliest arrival on the current network, under this case's congestion δ. One run per vehicle:</a:t>
-            </a:r>
-          </a:p>
-        </p:txBody>
-      </p:sp>
-      <p:sp>
-        <p:nvSpPr>
-          <p:cNvPr id="205" name="Rounded Rectangle 204"/>
-          <p:cNvSpPr/>
-          <p:nvPr/>
-        </p:nvSpPr>
-        <p:spPr>
-          <a:xfrm>
-            <a:off x="685800" y="1956816"/>
-            <a:ext cx="8321040" cy="2514600"/>
-          </a:xfrm>
-          <a:prstGeom prst="roundRect">
-            <a:avLst>
-              <a:gd name="adj" fmla="val 4000"/>
-            </a:avLst>
-          </a:prstGeom>
-          <a:solidFill>
-            <a:srgbClr val="F7F7F5"/>
-          </a:solidFill>
-          <a:ln w="15240">
-            <a:solidFill>
-              <a:srgbClr val="C9C8C2"/>
-            </a:solidFill>
-          </a:ln>
-          <a:effectLst/>
-        </p:spPr>
-        <p:style>
-          <a:lnRef idx="1">
-            <a:schemeClr val="accent1"/>
-          </a:lnRef>
-          <a:fillRef idx="3">
-            <a:schemeClr val="accent1"/>
-          </a:fillRef>
-          <a:effectRef idx="2">
-            <a:schemeClr val="accent1"/>
-          </a:effectRef>
-          <a:fontRef idx="minor">
-            <a:schemeClr val="lt1"/>
-          </a:fontRef>
-        </p:style>
-        <p:txBody>
-          <a:bodyPr rtlCol="0" anchor="ctr" wrap="none" lIns="128016" rIns="128016" tIns="54864" bIns="54864"/>
-          <a:lstStyle/>
-          <a:p>
-            <a:pPr algn="l">
-              <a:defRPr sz="960" b="1">
-                <a:solidFill>
-                  <a:srgbClr val="EB6834"/>
-                </a:solidFill>
-                <a:latin typeface="Courier New"/>
-              </a:defRPr>
-            </a:pPr>
-            <a:r>
-              <a:t>EarliestArrival(o, t₀, δ):        # one run per vehicle, on today's network</a:t>
-            </a:r>
-          </a:p>
-          <a:p>
-            <a:pPr algn="l">
-              <a:defRPr sz="960" b="0">
-                <a:solidFill>
-                  <a:srgbClr val="0B0B0B"/>
-                </a:solidFill>
-                <a:latin typeface="Courier New"/>
-              </a:defRPr>
-            </a:pPr>
-            <a:r>
-              <a:t>  entry[l] ← t₀  for every link l leaving gate o;  push (t₀, l)</a:t>
-            </a:r>
-          </a:p>
-          <a:p>
-            <a:pPr algn="l">
-              <a:defRPr sz="960" b="0">
-                <a:solidFill>
-                  <a:srgbClr val="0B0B0B"/>
-                </a:solidFill>
-                <a:latin typeface="Courier New"/>
-              </a:defRPr>
-            </a:pPr>
-            <a:r>
-              <a:t>  while queue not empty:</a:t>
-            </a:r>
-          </a:p>
-          <a:p>
-            <a:pPr algn="l">
-              <a:defRPr sz="960" b="0">
-                <a:solidFill>
-                  <a:srgbClr val="0B0B0B"/>
-                </a:solidFill>
-                <a:latin typeface="Courier New"/>
-              </a:defRPr>
-            </a:pPr>
-            <a:r>
-              <a:t>      (t, l) ← pop the SMALLEST entry time     # ordinary Dijkstra order</a:t>
-            </a:r>
-          </a:p>
-          <a:p>
-            <a:pPr algn="l">
-              <a:defRPr sz="960" b="0">
-                <a:solidFill>
-                  <a:srgbClr val="0B0B0B"/>
-                </a:solidFill>
-                <a:latin typeface="Courier New"/>
-              </a:defRPr>
-            </a:pPr>
-            <a:r>
-              <a:t>      if t &gt; entry[l]: continue                # stale label</a:t>
-            </a:r>
-          </a:p>
-          <a:p>
-            <a:pPr algn="l">
-              <a:defRPr sz="960" b="1">
-                <a:solidFill>
-                  <a:srgbClr val="EB6834"/>
-                </a:solidFill>
-                <a:latin typeface="Courier New"/>
-              </a:defRPr>
-            </a:pPr>
-            <a:r>
-              <a:t>      s ← t + c(l, t)      # exit time; the clock is INSIDE the cost</a:t>
-            </a:r>
-          </a:p>
-          <a:p>
-            <a:pPr algn="l">
-              <a:defRPr sz="960" b="0">
-                <a:solidFill>
-                  <a:srgbClr val="0B0B0B"/>
-                </a:solidFill>
-                <a:latin typeface="Courier New"/>
-              </a:defRPr>
-            </a:pPr>
-            <a:r>
-              <a:t>      if l ends at a gate g:  arrive[g] ← min(arrive[g], s)</a:t>
-            </a:r>
-          </a:p>
-          <a:p>
-            <a:pPr algn="l">
-              <a:defRPr sz="960" b="0">
-                <a:solidFill>
-                  <a:srgbClr val="0B0B0B"/>
-                </a:solidFill>
-                <a:latin typeface="Courier New"/>
-              </a:defRPr>
-            </a:pPr>
-            <a:r>
-              <a:t>      for every successor j of l (no U-turn):</a:t>
-            </a:r>
-          </a:p>
-          <a:p>
-            <a:pPr algn="l">
-              <a:defRPr sz="960" b="0">
-                <a:solidFill>
-                  <a:srgbClr val="0B0B0B"/>
-                </a:solidFill>
-                <a:latin typeface="Courier New"/>
-              </a:defRPr>
-            </a:pPr>
-            <a:r>
-              <a:t>          if s &lt; entry[j]:  entry[j] ← s;  push (s, j)</a:t>
-            </a:r>
-          </a:p>
-          <a:p>
-            <a:pPr algn="l">
-              <a:defRPr sz="960" b="0">
-                <a:solidFill>
-                  <a:srgbClr val="0B0B0B"/>
-                </a:solidFill>
-                <a:latin typeface="Courier New"/>
-              </a:defRPr>
-            </a:pPr>
-            <a:r>
-              <a:t>  return arrive                               # earliest arrival at EVERY gate</a:t>
-            </a:r>
-          </a:p>
-          <a:p>
-            <a:pPr algn="l">
-              <a:defRPr sz="960" b="0">
-                <a:solidFill>
-                  <a:srgbClr val="0B0B0B"/>
-                </a:solidFill>
-                <a:latin typeface="Courier New"/>
-              </a:defRPr>
-            </a:pPr>
-          </a:p>
-          <a:p>
-            <a:pPr algn="l">
-              <a:defRPr sz="960" b="1">
-                <a:solidFill>
-                  <a:srgbClr val="EB6834"/>
-                </a:solidFill>
-                <a:latin typeface="Courier New"/>
-              </a:defRPr>
-            </a:pPr>
-            <a:r>
-              <a:t>τᵐⁱⁿ_v = arrive[d_v] − t₀_v</a:t>
-            </a:r>
-          </a:p>
-        </p:txBody>
-      </p:sp>
-      <p:sp>
-        <p:nvSpPr>
-          <p:cNvPr id="206" name="Rounded Rectangle 205"/>
-          <p:cNvSpPr/>
-          <p:nvPr/>
-        </p:nvSpPr>
-        <p:spPr>
-          <a:xfrm>
-            <a:off x="9235440" y="1956816"/>
-            <a:ext cx="2468880" cy="2514600"/>
-          </a:xfrm>
-          <a:prstGeom prst="roundRect">
-            <a:avLst>
-              <a:gd name="adj" fmla="val 10000"/>
-            </a:avLst>
-          </a:prstGeom>
-          <a:solidFill>
-            <a:srgbClr val="FDF1E9"/>
-          </a:solidFill>
-          <a:ln w="15240">
-            <a:solidFill>
-              <a:srgbClr val="EB6834"/>
-            </a:solidFill>
-          </a:ln>
-          <a:effectLst/>
-        </p:spPr>
-        <p:style>
-          <a:lnRef idx="1">
-            <a:schemeClr val="accent1"/>
-          </a:lnRef>
-          <a:fillRef idx="3">
-            <a:schemeClr val="accent1"/>
-          </a:fillRef>
-          <a:effectRef idx="2">
-            <a:schemeClr val="accent1"/>
-          </a:effectRef>
-          <a:fontRef idx="minor">
-            <a:schemeClr val="lt1"/>
-          </a:fontRef>
-        </p:style>
-        <p:txBody>
-          <a:bodyPr rtlCol="0" anchor="ctr" wrap="square" lIns="54864" rIns="54864" tIns="27432" bIns="27432"/>
-          <a:lstStyle/>
-          <a:p>
-            <a:pPr algn="ctr">
-              <a:defRPr sz="1050" b="1">
-                <a:solidFill>
-                  <a:srgbClr val="EB6834"/>
-                </a:solidFill>
-              </a:defRPr>
-            </a:pPr>
-            <a:r>
-              <a:t>Where it runs</a:t>
-            </a:r>
-          </a:p>
-          <a:p>
-            <a:pPr algn="ctr">
-              <a:defRPr sz="860">
-                <a:solidFill>
-                  <a:srgbClr val="52514E"/>
-                </a:solidFill>
-              </a:defRPr>
-            </a:pPr>
-            <a:r>
-              <a:t>① budget assignment:</a:t>
-            </a:r>
-            <a:br/>
-            <a:r>
-              <a:t>V runs per case</a:t>
-            </a:r>
-            <a:br/>
-            <a:r>
-              <a:t>(~41 000 in the farm)</a:t>
-            </a:r>
-            <a:br/>
-            <a:br/>
-            <a:r>
-              <a:t>② decoder mask:</a:t>
-            </a:r>
-            <a:br/>
-            <a:r>
-              <a:t>min_finish(l, t, d) —</a:t>
-            </a:r>
-            <a:br/>
-            <a:r>
-              <a:t>same algorithm from one</a:t>
-            </a:r>
-            <a:br/>
-            <a:r>
-              <a:t>link, memoised</a:t>
-            </a:r>
-            <a:br/>
-            <a:br/>
-            <a:r>
-              <a:t>③ horizon calibration:</a:t>
-            </a:r>
-            <a:br/>
-            <a:r>
-              <a:t>once, all 8 gates</a:t>
-            </a:r>
-          </a:p>
-        </p:txBody>
-      </p:sp>
-      <p:sp>
-        <p:nvSpPr>
-          <p:cNvPr id="207" name="TextBox 206"/>
-          <p:cNvSpPr txBox="1"/>
-          <p:nvPr/>
-        </p:nvSpPr>
-        <p:spPr>
-          <a:xfrm>
-            <a:off x="640080" y="4709160"/>
-            <a:ext cx="11064240" cy="914400"/>
-          </a:xfrm>
-          <a:prstGeom prst="rect">
-            <a:avLst/>
-          </a:prstGeom>
-          <a:noFill/>
-        </p:spPr>
-        <p:txBody>
-          <a:bodyPr wrap="square">
-            <a:spAutoFit/>
-          </a:bodyPr>
-          <a:lstStyle/>
-          <a:p>
-            <a:pPr>
-              <a:defRPr sz="1200" b="1"/>
-            </a:pPr>
-            <a:r>
-              <a:t>• It is ordinary Dijkstra with ONE change: a label is a time, not a distance, and relaxing link l entered at time t costs c(l, t) — today's congestion δ sits inside c</a:t>
-            </a:r>
-          </a:p>
-          <a:p>
-            <a:pPr>
-              <a:defRPr sz="1200" b="0"/>
-            </a:pPr>
-            <a:r>
-              <a:t>• Why the greedy order stays correct: our costs are FIFO — t + c(l, t) never decreases in t (entering later can never mean exiting earlier), so the first label popped for a link is final, exactly the classic Dijkstra invariant</a:t>
-            </a:r>
-          </a:p>
-          <a:p>
-            <a:pPr>
-              <a:defRPr sz="1200" b="0"/>
-            </a:pPr>
-            <a:r>
-              <a:t>• One run touches at most 80 links → microseconds; ~41 000 runs across the whole farm are negligible next to the 0.90 s MILP solves. The mask's memoised queries are part of the 6–9 ms inference time</a:t>
             </a:r>
           </a:p>
         </p:txBody>
@@ -8564,6 +8278,616 @@
 </file>
 
 <file path=ppt/slides/slide20.xml><?xml version="1.0" encoding="utf-8"?>
+<p:sld xmlns:a="http://schemas.openxmlformats.org/drawingml/2006/main" xmlns:p="http://schemas.openxmlformats.org/presentationml/2006/main" xmlns:r="http://schemas.openxmlformats.org/officeDocument/2006/relationships">
+  <p:cSld>
+    <p:spTree>
+      <p:nvGrpSpPr>
+        <p:cNvPr id="1" name=""/>
+        <p:cNvGrpSpPr/>
+        <p:nvPr/>
+      </p:nvGrpSpPr>
+      <p:grpSpPr/>
+      <p:sp>
+        <p:nvSpPr>
+          <p:cNvPr id="7" name="文本占位符 6">
+            <a:extLst>
+              <a:ext uri="{FF2B5EF4-FFF2-40B4-BE49-F238E27FC236}">
+                <a16:creationId xmlns:a16="http://schemas.microsoft.com/office/drawing/2014/main" id="{33AE8DB3-4C29-0DE3-EB73-8D2BBFBB8CBF}"/>
+              </a:ext>
+            </a:extLst>
+          </p:cNvPr>
+          <p:cNvSpPr>
+            <a:spLocks noGrp="1"/>
+          </p:cNvSpPr>
+          <p:nvPr>
+            <p:ph type="body" sz="quarter" idx="11"/>
+          </p:nvPr>
+        </p:nvSpPr>
+        <p:spPr>
+          <a:xfrm>
+            <a:off x="336550" y="58738"/>
+            <a:ext cx="5759450" cy="622300"/>
+          </a:xfrm>
+        </p:spPr>
+        <p:txBody>
+          <a:bodyPr/>
+          <a:lstStyle/>
+          <a:p>
+            <a:r>
+              <a:rPr lang="en-US" altLang="zh-CN" dirty="0"/>
+              <a:t>Change (a) — objective</a:t>
+            </a:r>
+            <a:endParaRPr lang="zh-CN" altLang="en-US" dirty="0"/>
+          </a:p>
+        </p:txBody>
+      </p:sp>
+      <p:sp>
+        <p:nvSpPr>
+          <p:cNvPr id="203" name="文本占位符 5">
+            <a:extLst>
+              <a:ext uri="{FF2B5EF4-FFF2-40B4-BE49-F238E27FC236}">
+                <a16:creationId xmlns:a16="http://schemas.microsoft.com/office/drawing/2014/main" id="{A219F0BA-71F5-BA11-CCBD-9327897B98CC}"/>
+              </a:ext>
+            </a:extLst>
+          </p:cNvPr>
+          <p:cNvSpPr>
+            <a:spLocks noGrp="1"/>
+          </p:cNvSpPr>
+          <p:nvPr>
+            <p:ph type="body" sz="quarter" idx="10"/>
+          </p:nvPr>
+        </p:nvSpPr>
+        <p:spPr>
+          <a:xfrm>
+            <a:off x="0" y="820290"/>
+            <a:ext cx="5878224" cy="638175"/>
+          </a:xfrm>
+        </p:spPr>
+        <p:txBody>
+          <a:bodyPr/>
+          <a:lstStyle/>
+          <a:p>
+            <a:r>
+              <a:rPr lang="en-US" altLang="zh-CN" sz="2800" dirty="0"/>
+              <a:t>Switch vs dial — measured</a:t>
+            </a:r>
+            <a:endParaRPr lang="zh-CN" altLang="en-US" sz="2800" dirty="0"/>
+          </a:p>
+        </p:txBody>
+      </p:sp>
+      <p:pic>
+        <p:nvPicPr>
+          <p:cNvPr id="204" name="Picture 203" descr="figS1_knob_vs_switch.png"/>
+          <p:cNvPicPr>
+            <a:picLocks noChangeAspect="1"/>
+          </p:cNvPicPr>
+          <p:nvPr/>
+        </p:nvPicPr>
+        <p:blipFill>
+          <a:blip r:embed="rId2"/>
+          <a:stretch>
+            <a:fillRect/>
+          </a:stretch>
+        </p:blipFill>
+        <p:spPr>
+          <a:xfrm>
+            <a:off x="792327" y="1371600"/>
+            <a:ext cx="10607040" cy="4060090"/>
+          </a:xfrm>
+          <a:prstGeom prst="rect">
+            <a:avLst/>
+          </a:prstGeom>
+        </p:spPr>
+      </p:pic>
+      <p:sp>
+        <p:nvSpPr>
+          <p:cNvPr id="205" name="TextBox 204"/>
+          <p:cNvSpPr txBox="1"/>
+          <p:nvPr/>
+        </p:nvSpPr>
+        <p:spPr>
+          <a:xfrm>
+            <a:off x="640080" y="5523129"/>
+            <a:ext cx="10881360" cy="914400"/>
+          </a:xfrm>
+          <a:prstGeom prst="rect">
+            <a:avLst/>
+          </a:prstGeom>
+          <a:noFill/>
+        </p:spPr>
+        <p:txBody>
+          <a:bodyPr wrap="square">
+            <a:spAutoFit/>
+          </a:bodyPr>
+          <a:lstStyle/>
+          <a:p>
+            <a:pPr>
+              <a:defRPr sz="1250" b="0"/>
+            </a:pPr>
+            <a:r>
+              <a:t>• One fixed instance, one MILP, one solver, MIPGap 0.5 %. LEFT: 13 values of α₂ with the budget fixed at H → 2 distinct solutions (α₂ = 0.10–0.48 identical link-for-link). RIGHT: α frozen at 0.3/0.7, per-vehicle budget swept → 10 distinct, monotone solutions</a:t>
+            </a:r>
+          </a:p>
+        </p:txBody>
+      </p:sp>
+    </p:spTree>
+  </p:cSld>
+  <p:clrMapOvr>
+    <a:masterClrMapping/>
+  </p:clrMapOvr>
+</p:sld>
+</file>
+
+<file path=ppt/slides/slide21.xml><?xml version="1.0" encoding="utf-8"?>
+<p:sld xmlns:a="http://schemas.openxmlformats.org/drawingml/2006/main" xmlns:p="http://schemas.openxmlformats.org/presentationml/2006/main" xmlns:r="http://schemas.openxmlformats.org/officeDocument/2006/relationships">
+  <p:cSld>
+    <p:spTree>
+      <p:nvGrpSpPr>
+        <p:cNvPr id="1" name=""/>
+        <p:cNvGrpSpPr/>
+        <p:nvPr/>
+      </p:nvGrpSpPr>
+      <p:grpSpPr/>
+      <p:sp>
+        <p:nvSpPr>
+          <p:cNvPr id="7" name="文本占位符 6">
+            <a:extLst>
+              <a:ext uri="{FF2B5EF4-FFF2-40B4-BE49-F238E27FC236}">
+                <a16:creationId xmlns:a16="http://schemas.microsoft.com/office/drawing/2014/main" id="{33AE8DB3-4C29-0DE3-EB73-8D2BBFBB8CBF}"/>
+              </a:ext>
+            </a:extLst>
+          </p:cNvPr>
+          <p:cNvSpPr>
+            <a:spLocks noGrp="1"/>
+          </p:cNvSpPr>
+          <p:nvPr>
+            <p:ph type="body" sz="quarter" idx="11"/>
+          </p:nvPr>
+        </p:nvSpPr>
+        <p:spPr>
+          <a:xfrm>
+            <a:off x="336550" y="58738"/>
+            <a:ext cx="5759450" cy="622300"/>
+          </a:xfrm>
+        </p:spPr>
+        <p:txBody>
+          <a:bodyPr/>
+          <a:lstStyle/>
+          <a:p>
+            <a:r>
+              <a:rPr lang="en-US" altLang="zh-CN" dirty="0"/>
+              <a:t>Change (a) — objective</a:t>
+            </a:r>
+            <a:endParaRPr lang="zh-CN" altLang="en-US" dirty="0"/>
+          </a:p>
+        </p:txBody>
+      </p:sp>
+      <p:sp>
+        <p:nvSpPr>
+          <p:cNvPr id="203" name="文本占位符 5">
+            <a:extLst>
+              <a:ext uri="{FF2B5EF4-FFF2-40B4-BE49-F238E27FC236}">
+                <a16:creationId xmlns:a16="http://schemas.microsoft.com/office/drawing/2014/main" id="{A219F0BA-71F5-BA11-CCBD-9327897B98CC}"/>
+              </a:ext>
+            </a:extLst>
+          </p:cNvPr>
+          <p:cNvSpPr>
+            <a:spLocks noGrp="1"/>
+          </p:cNvSpPr>
+          <p:nvPr>
+            <p:ph type="body" sz="quarter" idx="10"/>
+          </p:nvPr>
+        </p:nvSpPr>
+        <p:spPr>
+          <a:xfrm>
+            <a:off x="0" y="820290"/>
+            <a:ext cx="5878224" cy="638175"/>
+          </a:xfrm>
+        </p:spPr>
+        <p:txBody>
+          <a:bodyPr/>
+          <a:lstStyle/>
+          <a:p>
+            <a:r>
+              <a:rPr lang="en-US" altLang="zh-CN" sz="2800" dirty="0"/>
+              <a:t>Step 0: earliest arrival</a:t>
+            </a:r>
+            <a:endParaRPr lang="zh-CN" altLang="en-US" sz="2800" dirty="0"/>
+          </a:p>
+        </p:txBody>
+      </p:sp>
+      <p:sp>
+        <p:nvSpPr>
+          <p:cNvPr id="204" name="TextBox 203"/>
+          <p:cNvSpPr txBox="1"/>
+          <p:nvPr/>
+        </p:nvSpPr>
+        <p:spPr>
+          <a:xfrm>
+            <a:off x="685800" y="1353312"/>
+            <a:ext cx="10881360" cy="274320"/>
+          </a:xfrm>
+          <a:prstGeom prst="rect">
+            <a:avLst/>
+          </a:prstGeom>
+          <a:noFill/>
+        </p:spPr>
+        <p:txBody>
+          <a:bodyPr wrap="square">
+            <a:spAutoFit/>
+          </a:bodyPr>
+          <a:lstStyle/>
+          <a:p>
+            <a:pPr algn="l">
+              <a:defRPr sz="1250" b="1">
+                <a:solidFill>
+                  <a:srgbClr val="52514E"/>
+                </a:solidFill>
+              </a:defRPr>
+            </a:pPr>
+            <a:r>
+              <a:t>Before any budget can be set, we must know the fastest this vehicle could possibly make its trip TODAY — earliest arrival on the current network, under this case's congestion δ. One run per vehicle:</a:t>
+            </a:r>
+          </a:p>
+        </p:txBody>
+      </p:sp>
+      <p:sp>
+        <p:nvSpPr>
+          <p:cNvPr id="205" name="Rounded Rectangle 204"/>
+          <p:cNvSpPr/>
+          <p:nvPr/>
+        </p:nvSpPr>
+        <p:spPr>
+          <a:xfrm>
+            <a:off x="685800" y="1956816"/>
+            <a:ext cx="8321040" cy="2514600"/>
+          </a:xfrm>
+          <a:prstGeom prst="roundRect">
+            <a:avLst>
+              <a:gd name="adj" fmla="val 4000"/>
+            </a:avLst>
+          </a:prstGeom>
+          <a:solidFill>
+            <a:srgbClr val="F7F7F5"/>
+          </a:solidFill>
+          <a:ln w="15240">
+            <a:solidFill>
+              <a:srgbClr val="C9C8C2"/>
+            </a:solidFill>
+          </a:ln>
+          <a:effectLst/>
+        </p:spPr>
+        <p:style>
+          <a:lnRef idx="1">
+            <a:schemeClr val="accent1"/>
+          </a:lnRef>
+          <a:fillRef idx="3">
+            <a:schemeClr val="accent1"/>
+          </a:fillRef>
+          <a:effectRef idx="2">
+            <a:schemeClr val="accent1"/>
+          </a:effectRef>
+          <a:fontRef idx="minor">
+            <a:schemeClr val="lt1"/>
+          </a:fontRef>
+        </p:style>
+        <p:txBody>
+          <a:bodyPr rtlCol="0" anchor="ctr" wrap="none" lIns="128016" rIns="128016" tIns="54864" bIns="54864"/>
+          <a:lstStyle/>
+          <a:p>
+            <a:pPr algn="l">
+              <a:defRPr sz="960" b="1">
+                <a:solidFill>
+                  <a:srgbClr val="EB6834"/>
+                </a:solidFill>
+                <a:latin typeface="Courier New"/>
+              </a:defRPr>
+            </a:pPr>
+            <a:r>
+              <a:t>EarliestArrival(o, t₀, δ):        # one run per vehicle, on today's network</a:t>
+            </a:r>
+          </a:p>
+          <a:p>
+            <a:pPr algn="l">
+              <a:defRPr sz="960" b="0">
+                <a:solidFill>
+                  <a:srgbClr val="0B0B0B"/>
+                </a:solidFill>
+                <a:latin typeface="Courier New"/>
+              </a:defRPr>
+            </a:pPr>
+            <a:r>
+              <a:t>  entry[l] ← t₀  for every link l leaving gate o;  push (t₀, l)</a:t>
+            </a:r>
+          </a:p>
+          <a:p>
+            <a:pPr algn="l">
+              <a:defRPr sz="960" b="0">
+                <a:solidFill>
+                  <a:srgbClr val="0B0B0B"/>
+                </a:solidFill>
+                <a:latin typeface="Courier New"/>
+              </a:defRPr>
+            </a:pPr>
+            <a:r>
+              <a:t>  while queue not empty:</a:t>
+            </a:r>
+          </a:p>
+          <a:p>
+            <a:pPr algn="l">
+              <a:defRPr sz="960" b="0">
+                <a:solidFill>
+                  <a:srgbClr val="0B0B0B"/>
+                </a:solidFill>
+                <a:latin typeface="Courier New"/>
+              </a:defRPr>
+            </a:pPr>
+            <a:r>
+              <a:t>      (t, l) ← pop the SMALLEST entry time     # ordinary Dijkstra order</a:t>
+            </a:r>
+          </a:p>
+          <a:p>
+            <a:pPr algn="l">
+              <a:defRPr sz="960" b="0">
+                <a:solidFill>
+                  <a:srgbClr val="0B0B0B"/>
+                </a:solidFill>
+                <a:latin typeface="Courier New"/>
+              </a:defRPr>
+            </a:pPr>
+            <a:r>
+              <a:t>      if t &gt; entry[l]: continue                # stale label</a:t>
+            </a:r>
+          </a:p>
+          <a:p>
+            <a:pPr algn="l">
+              <a:defRPr sz="960" b="1">
+                <a:solidFill>
+                  <a:srgbClr val="EB6834"/>
+                </a:solidFill>
+                <a:latin typeface="Courier New"/>
+              </a:defRPr>
+            </a:pPr>
+            <a:r>
+              <a:t>      s ← t + c(l, t)      # exit time; the clock is INSIDE the cost</a:t>
+            </a:r>
+          </a:p>
+          <a:p>
+            <a:pPr algn="l">
+              <a:defRPr sz="960" b="0">
+                <a:solidFill>
+                  <a:srgbClr val="0B0B0B"/>
+                </a:solidFill>
+                <a:latin typeface="Courier New"/>
+              </a:defRPr>
+            </a:pPr>
+            <a:r>
+              <a:t>      if l ends at a gate g:  arrive[g] ← min(arrive[g], s)</a:t>
+            </a:r>
+          </a:p>
+          <a:p>
+            <a:pPr algn="l">
+              <a:defRPr sz="960" b="0">
+                <a:solidFill>
+                  <a:srgbClr val="0B0B0B"/>
+                </a:solidFill>
+                <a:latin typeface="Courier New"/>
+              </a:defRPr>
+            </a:pPr>
+            <a:r>
+              <a:t>      for every successor j of l (no U-turn):</a:t>
+            </a:r>
+          </a:p>
+          <a:p>
+            <a:pPr algn="l">
+              <a:defRPr sz="960" b="0">
+                <a:solidFill>
+                  <a:srgbClr val="0B0B0B"/>
+                </a:solidFill>
+                <a:latin typeface="Courier New"/>
+              </a:defRPr>
+            </a:pPr>
+            <a:r>
+              <a:t>          if s &lt; entry[j]:  entry[j] ← s;  push (s, j)</a:t>
+            </a:r>
+          </a:p>
+          <a:p>
+            <a:pPr algn="l">
+              <a:defRPr sz="960" b="0">
+                <a:solidFill>
+                  <a:srgbClr val="0B0B0B"/>
+                </a:solidFill>
+                <a:latin typeface="Courier New"/>
+              </a:defRPr>
+            </a:pPr>
+            <a:r>
+              <a:t>  return arrive                               # earliest arrival at EVERY gate</a:t>
+            </a:r>
+          </a:p>
+          <a:p>
+            <a:pPr algn="l">
+              <a:defRPr sz="960" b="0">
+                <a:solidFill>
+                  <a:srgbClr val="0B0B0B"/>
+                </a:solidFill>
+                <a:latin typeface="Courier New"/>
+              </a:defRPr>
+            </a:pPr>
+          </a:p>
+          <a:p>
+            <a:pPr algn="l">
+              <a:defRPr sz="960" b="1">
+                <a:solidFill>
+                  <a:srgbClr val="EB6834"/>
+                </a:solidFill>
+                <a:latin typeface="Courier New"/>
+              </a:defRPr>
+            </a:pPr>
+            <a:r>
+              <a:t>τᵐⁱⁿ_v = arrive[d_v] − t₀_v</a:t>
+            </a:r>
+          </a:p>
+        </p:txBody>
+      </p:sp>
+      <p:sp>
+        <p:nvSpPr>
+          <p:cNvPr id="206" name="Rounded Rectangle 205"/>
+          <p:cNvSpPr/>
+          <p:nvPr/>
+        </p:nvSpPr>
+        <p:spPr>
+          <a:xfrm>
+            <a:off x="9235440" y="1956816"/>
+            <a:ext cx="2468880" cy="2514600"/>
+          </a:xfrm>
+          <a:prstGeom prst="roundRect">
+            <a:avLst>
+              <a:gd name="adj" fmla="val 10000"/>
+            </a:avLst>
+          </a:prstGeom>
+          <a:solidFill>
+            <a:srgbClr val="FDF1E9"/>
+          </a:solidFill>
+          <a:ln w="15240">
+            <a:solidFill>
+              <a:srgbClr val="EB6834"/>
+            </a:solidFill>
+          </a:ln>
+          <a:effectLst/>
+        </p:spPr>
+        <p:style>
+          <a:lnRef idx="1">
+            <a:schemeClr val="accent1"/>
+          </a:lnRef>
+          <a:fillRef idx="3">
+            <a:schemeClr val="accent1"/>
+          </a:fillRef>
+          <a:effectRef idx="2">
+            <a:schemeClr val="accent1"/>
+          </a:effectRef>
+          <a:fontRef idx="minor">
+            <a:schemeClr val="lt1"/>
+          </a:fontRef>
+        </p:style>
+        <p:txBody>
+          <a:bodyPr rtlCol="0" anchor="ctr" wrap="square" lIns="54864" rIns="54864" tIns="27432" bIns="27432"/>
+          <a:lstStyle/>
+          <a:p>
+            <a:pPr algn="ctr">
+              <a:defRPr sz="1050" b="1">
+                <a:solidFill>
+                  <a:srgbClr val="EB6834"/>
+                </a:solidFill>
+              </a:defRPr>
+            </a:pPr>
+            <a:r>
+              <a:t>Where it runs</a:t>
+            </a:r>
+          </a:p>
+          <a:p>
+            <a:pPr algn="ctr">
+              <a:defRPr sz="860">
+                <a:solidFill>
+                  <a:srgbClr val="52514E"/>
+                </a:solidFill>
+              </a:defRPr>
+            </a:pPr>
+            <a:r>
+              <a:t>① budget assignment:</a:t>
+            </a:r>
+            <a:br/>
+            <a:r>
+              <a:t>V runs per case</a:t>
+            </a:r>
+            <a:br/>
+            <a:r>
+              <a:t>(~41 000 in the farm)</a:t>
+            </a:r>
+            <a:br/>
+            <a:br/>
+            <a:r>
+              <a:t>② decoder mask:</a:t>
+            </a:r>
+            <a:br/>
+            <a:r>
+              <a:t>min_finish(l, t, d) —</a:t>
+            </a:r>
+            <a:br/>
+            <a:r>
+              <a:t>same algorithm from one</a:t>
+            </a:r>
+            <a:br/>
+            <a:r>
+              <a:t>link, memoised</a:t>
+            </a:r>
+            <a:br/>
+            <a:br/>
+            <a:r>
+              <a:t>③ horizon calibration:</a:t>
+            </a:r>
+            <a:br/>
+            <a:r>
+              <a:t>once, all 8 gates</a:t>
+            </a:r>
+          </a:p>
+        </p:txBody>
+      </p:sp>
+      <p:sp>
+        <p:nvSpPr>
+          <p:cNvPr id="207" name="TextBox 206"/>
+          <p:cNvSpPr txBox="1"/>
+          <p:nvPr/>
+        </p:nvSpPr>
+        <p:spPr>
+          <a:xfrm>
+            <a:off x="640080" y="4709160"/>
+            <a:ext cx="11064240" cy="914400"/>
+          </a:xfrm>
+          <a:prstGeom prst="rect">
+            <a:avLst/>
+          </a:prstGeom>
+          <a:noFill/>
+        </p:spPr>
+        <p:txBody>
+          <a:bodyPr wrap="square">
+            <a:spAutoFit/>
+          </a:bodyPr>
+          <a:lstStyle/>
+          <a:p>
+            <a:pPr>
+              <a:defRPr sz="1200" b="1"/>
+            </a:pPr>
+            <a:r>
+              <a:t>• It is ordinary Dijkstra with ONE change: a label is a time, not a distance, and relaxing link l entered at time t costs c(l, t) — today's congestion δ sits inside c</a:t>
+            </a:r>
+          </a:p>
+          <a:p>
+            <a:pPr>
+              <a:defRPr sz="1200" b="0"/>
+            </a:pPr>
+            <a:r>
+              <a:t>• Why the greedy order stays correct: our costs are FIFO — t + c(l, t) never decreases in t (entering later can never mean exiting earlier), so the first label popped for a link is final, exactly the classic Dijkstra invariant</a:t>
+            </a:r>
+          </a:p>
+          <a:p>
+            <a:pPr>
+              <a:defRPr sz="1200" b="0"/>
+            </a:pPr>
+            <a:r>
+              <a:t>• One run touches at most 80 links → microseconds; ~41 000 runs across the whole farm are negligible next to the 0.90 s MILP solves. The mask's memoised queries are part of the 6–9 ms inference time</a:t>
+            </a:r>
+          </a:p>
+        </p:txBody>
+      </p:sp>
+    </p:spTree>
+  </p:cSld>
+  <p:clrMapOvr>
+    <a:masterClrMapping/>
+  </p:clrMapOvr>
+</p:sld>
+</file>
+
+<file path=ppt/slides/slide22.xml><?xml version="1.0" encoding="utf-8"?>
 <p:sld xmlns:a="http://schemas.openxmlformats.org/drawingml/2006/main" xmlns:p="http://schemas.openxmlformats.org/presentationml/2006/main" xmlns:r="http://schemas.openxmlformats.org/officeDocument/2006/relationships">
   <p:cSld>
     <p:spTree>
@@ -8803,7 +9127,7 @@
 </p:sld>
 </file>
 
-<file path=ppt/slides/slide21.xml><?xml version="1.0" encoding="utf-8"?>
+<file path=ppt/slides/slide23.xml><?xml version="1.0" encoding="utf-8"?>
 <p:sld xmlns:a="http://schemas.openxmlformats.org/drawingml/2006/main" xmlns:p="http://schemas.openxmlformats.org/presentationml/2006/main" xmlns:r="http://schemas.openxmlformats.org/officeDocument/2006/relationships">
   <p:cSld>
     <p:spTree>
@@ -10718,7 +11042,7 @@
 </p:sld>
 </file>
 
-<file path=ppt/slides/slide22.xml><?xml version="1.0" encoding="utf-8"?>
+<file path=ppt/slides/slide24.xml><?xml version="1.0" encoding="utf-8"?>
 <p:sld xmlns:a="http://schemas.openxmlformats.org/drawingml/2006/main" xmlns:p="http://schemas.openxmlformats.org/presentationml/2006/main" xmlns:r="http://schemas.openxmlformats.org/officeDocument/2006/relationships">
   <p:cSld>
     <p:spTree>
@@ -10899,7 +11223,7 @@
 </p:sld>
 </file>
 
-<file path=ppt/slides/slide23.xml><?xml version="1.0" encoding="utf-8"?>
+<file path=ppt/slides/slide25.xml><?xml version="1.0" encoding="utf-8"?>
 <p:sld xmlns:a="http://schemas.openxmlformats.org/drawingml/2006/main" xmlns:p="http://schemas.openxmlformats.org/presentationml/2006/main" xmlns:r="http://schemas.openxmlformats.org/officeDocument/2006/relationships">
   <p:cSld>
     <p:spTree>
@@ -12053,7 +12377,7 @@
 </p:sld>
 </file>
 
-<file path=ppt/slides/slide24.xml><?xml version="1.0" encoding="utf-8"?>
+<file path=ppt/slides/slide26.xml><?xml version="1.0" encoding="utf-8"?>
 <p:sld xmlns:a="http://schemas.openxmlformats.org/drawingml/2006/main" xmlns:p="http://schemas.openxmlformats.org/presentationml/2006/main" xmlns:r="http://schemas.openxmlformats.org/officeDocument/2006/relationships">
   <p:cSld>
     <p:spTree>
@@ -12824,7 +13148,7 @@
 </p:sld>
 </file>
 
-<file path=ppt/slides/slide25.xml><?xml version="1.0" encoding="utf-8"?>
+<file path=ppt/slides/slide27.xml><?xml version="1.0" encoding="utf-8"?>
 <p:sld xmlns:a="http://schemas.openxmlformats.org/drawingml/2006/main" xmlns:p="http://schemas.openxmlformats.org/presentationml/2006/main" xmlns:r="http://schemas.openxmlformats.org/officeDocument/2006/relationships">
   <p:cSld>
     <p:spTree>
@@ -13650,7 +13974,7 @@
 </p:sld>
 </file>
 
-<file path=ppt/slides/slide26.xml><?xml version="1.0" encoding="utf-8"?>
+<file path=ppt/slides/slide28.xml><?xml version="1.0" encoding="utf-8"?>
 <p:sld xmlns:a="http://schemas.openxmlformats.org/drawingml/2006/main" xmlns:p="http://schemas.openxmlformats.org/presentationml/2006/main" xmlns:r="http://schemas.openxmlformats.org/officeDocument/2006/relationships">
   <p:cSld>
     <p:spTree>
@@ -14946,7 +15270,7 @@
 </p:sld>
 </file>
 
-<file path=ppt/slides/slide27.xml><?xml version="1.0" encoding="utf-8"?>
+<file path=ppt/slides/slide29.xml><?xml version="1.0" encoding="utf-8"?>
 <p:sld xmlns:a="http://schemas.openxmlformats.org/drawingml/2006/main" xmlns:p="http://schemas.openxmlformats.org/presentationml/2006/main" xmlns:r="http://schemas.openxmlformats.org/officeDocument/2006/relationships">
   <p:cSld>
     <p:spTree>
@@ -16218,360 +16542,6 @@
 </p:sld>
 </file>
 
-<file path=ppt/slides/slide28.xml><?xml version="1.0" encoding="utf-8"?>
-<p:sld xmlns:a="http://schemas.openxmlformats.org/drawingml/2006/main" xmlns:p="http://schemas.openxmlformats.org/presentationml/2006/main" xmlns:r="http://schemas.openxmlformats.org/officeDocument/2006/relationships">
-  <p:cSld>
-    <p:spTree>
-      <p:nvGrpSpPr>
-        <p:cNvPr id="1" name=""/>
-        <p:cNvGrpSpPr/>
-        <p:nvPr/>
-      </p:nvGrpSpPr>
-      <p:grpSpPr/>
-      <p:sp>
-        <p:nvSpPr>
-          <p:cNvPr id="7" name="文本占位符 6">
-            <a:extLst>
-              <a:ext uri="{FF2B5EF4-FFF2-40B4-BE49-F238E27FC236}">
-                <a16:creationId xmlns:a16="http://schemas.microsoft.com/office/drawing/2014/main" id="{33AE8DB3-4C29-0DE3-EB73-8D2BBFBB8CBF}"/>
-              </a:ext>
-            </a:extLst>
-          </p:cNvPr>
-          <p:cNvSpPr>
-            <a:spLocks noGrp="1"/>
-          </p:cNvSpPr>
-          <p:nvPr>
-            <p:ph type="body" sz="quarter" idx="11"/>
-          </p:nvPr>
-        </p:nvSpPr>
-        <p:spPr>
-          <a:xfrm>
-            <a:off x="336550" y="58738"/>
-            <a:ext cx="5759450" cy="622300"/>
-          </a:xfrm>
-        </p:spPr>
-        <p:txBody>
-          <a:bodyPr/>
-          <a:lstStyle/>
-          <a:p>
-            <a:r>
-              <a:rPr lang="en-US" altLang="zh-CN" dirty="0"/>
-              <a:t>Data</a:t>
-            </a:r>
-            <a:endParaRPr lang="zh-CN" altLang="en-US" dirty="0"/>
-          </a:p>
-        </p:txBody>
-      </p:sp>
-      <p:sp>
-        <p:nvSpPr>
-          <p:cNvPr id="203" name="文本占位符 5">
-            <a:extLst>
-              <a:ext uri="{FF2B5EF4-FFF2-40B4-BE49-F238E27FC236}">
-                <a16:creationId xmlns:a16="http://schemas.microsoft.com/office/drawing/2014/main" id="{A219F0BA-71F5-BA11-CCBD-9327897B98CC}"/>
-              </a:ext>
-            </a:extLst>
-          </p:cNvPr>
-          <p:cNvSpPr>
-            <a:spLocks noGrp="1"/>
-          </p:cNvSpPr>
-          <p:nvPr>
-            <p:ph type="body" sz="quarter" idx="10"/>
-          </p:nvPr>
-        </p:nvSpPr>
-        <p:spPr>
-          <a:xfrm>
-            <a:off x="0" y="820290"/>
-            <a:ext cx="5878224" cy="638175"/>
-          </a:xfrm>
-        </p:spPr>
-        <p:txBody>
-          <a:bodyPr/>
-          <a:lstStyle/>
-          <a:p>
-            <a:r>
-              <a:rPr lang="en-US" altLang="zh-CN" sz="2800" dirty="0"/>
-              <a:t>Label set</a:t>
-            </a:r>
-            <a:endParaRPr lang="zh-CN" altLang="en-US" sz="2800" dirty="0"/>
-          </a:p>
-        </p:txBody>
-      </p:sp>
-      <p:sp>
-        <p:nvSpPr>
-          <p:cNvPr id="204" name="TextBox 203"/>
-          <p:cNvSpPr txBox="1"/>
-          <p:nvPr/>
-        </p:nvSpPr>
-        <p:spPr>
-          <a:xfrm>
-            <a:off x="640080" y="1508760"/>
-            <a:ext cx="10881360" cy="914400"/>
-          </a:xfrm>
-          <a:prstGeom prst="rect">
-            <a:avLst/>
-          </a:prstGeom>
-          <a:noFill/>
-        </p:spPr>
-        <p:txBody>
-          <a:bodyPr wrap="square">
-            <a:spAutoFit/>
-          </a:bodyPr>
-          <a:lstStyle/>
-          <a:p>
-            <a:pPr>
-              <a:defRPr sz="1350" b="1"/>
-            </a:pPr>
-            <a:r>
-              <a:t>• 10 780 Gurobi labels · 0 errors · 0 solves hit the 60 s cap · 0.90 s mean per case (tight budgets prune the time-expanded graph → labelling ~30× faster than the full-horizon farm) · ~17 min on 15 workers, fully resumable</a:t>
-            </a:r>
-          </a:p>
-          <a:p>
-            <a:pPr>
-              <a:defRPr sz="1350" b="1"/>
-            </a:pPr>
-            <a:r>
-              <a:t>• Shards:</a:t>
-            </a:r>
-          </a:p>
-          <a:p>
-            <a:pPr>
-              <a:defRPr sz="1200" b="0"/>
-            </a:pPr>
-            <a:r>
-              <a:t>   – train 8 000 · same-distribution test 800</a:t>
-            </a:r>
-          </a:p>
-          <a:p>
-            <a:pPr>
-              <a:defRPr sz="1200" b="0"/>
-            </a:pPr>
-            <a:r>
-              <a:t>   – OD zero-shot 400 (4 gate pairs never trained) · fleet extrapolation 400 (V ∈ {5,8})</a:t>
-            </a:r>
-          </a:p>
-          <a:p>
-            <a:pPr>
-              <a:defRPr sz="1200" b="0"/>
-            </a:pPr>
-            <a:r>
-              <a:t>   – UNSEEN-budget interpolation 400 (ρ ∈ {1.25, 1.75}) · extrapolation 300 (ρ = 4.0)</a:t>
-            </a:r>
-          </a:p>
-          <a:p>
-            <a:pPr>
-              <a:defRPr sz="1200" b="0"/>
-            </a:pPr>
-            <a:r>
-              <a:t>   – response curve: 60 fixed instances × 8 ρ values, re-solved by Gurobi at every ρ</a:t>
-            </a:r>
-          </a:p>
-          <a:p>
-            <a:pPr>
-              <a:defRPr sz="1350" b="0"/>
-            </a:pPr>
-            <a:r>
-              <a:t>• Trained ρ anchors {1.0, 1.5, 2.0, 3.0}; the three held-out ρ values appear in NO training label</a:t>
-            </a:r>
-          </a:p>
-          <a:p>
-            <a:pPr>
-              <a:defRPr sz="1350" b="0"/>
-            </a:pPr>
-            <a:r>
-              <a:t>• Every label passes two checks at write time: flow-decomposed objective ≡ Gurobi ObjVal (1e-6) and every per-vehicle deadline re-validated</a:t>
-            </a:r>
-          </a:p>
-        </p:txBody>
-      </p:sp>
-    </p:spTree>
-  </p:cSld>
-  <p:clrMapOvr>
-    <a:masterClrMapping/>
-  </p:clrMapOvr>
-</p:sld>
-</file>
-
-<file path=ppt/slides/slide29.xml><?xml version="1.0" encoding="utf-8"?>
-<p:sld xmlns:a="http://schemas.openxmlformats.org/drawingml/2006/main" xmlns:p="http://schemas.openxmlformats.org/presentationml/2006/main" xmlns:r="http://schemas.openxmlformats.org/officeDocument/2006/relationships">
-  <p:cSld>
-    <p:spTree>
-      <p:nvGrpSpPr>
-        <p:cNvPr id="1" name=""/>
-        <p:cNvGrpSpPr/>
-        <p:nvPr/>
-      </p:nvGrpSpPr>
-      <p:grpSpPr/>
-      <p:sp>
-        <p:nvSpPr>
-          <p:cNvPr id="7" name="文本占位符 6">
-            <a:extLst>
-              <a:ext uri="{FF2B5EF4-FFF2-40B4-BE49-F238E27FC236}">
-                <a16:creationId xmlns:a16="http://schemas.microsoft.com/office/drawing/2014/main" id="{33AE8DB3-4C29-0DE3-EB73-8D2BBFBB8CBF}"/>
-              </a:ext>
-            </a:extLst>
-          </p:cNvPr>
-          <p:cNvSpPr>
-            <a:spLocks noGrp="1"/>
-          </p:cNvSpPr>
-          <p:nvPr>
-            <p:ph type="body" sz="quarter" idx="11"/>
-          </p:nvPr>
-        </p:nvSpPr>
-        <p:spPr>
-          <a:xfrm>
-            <a:off x="336550" y="58738"/>
-            <a:ext cx="5759450" cy="622300"/>
-          </a:xfrm>
-        </p:spPr>
-        <p:txBody>
-          <a:bodyPr/>
-          <a:lstStyle/>
-          <a:p>
-            <a:r>
-              <a:rPr lang="en-US" altLang="zh-CN" dirty="0"/>
-              <a:t>Evaluation</a:t>
-            </a:r>
-            <a:endParaRPr lang="zh-CN" altLang="en-US" dirty="0"/>
-          </a:p>
-        </p:txBody>
-      </p:sp>
-      <p:sp>
-        <p:nvSpPr>
-          <p:cNvPr id="203" name="文本占位符 5">
-            <a:extLst>
-              <a:ext uri="{FF2B5EF4-FFF2-40B4-BE49-F238E27FC236}">
-                <a16:creationId xmlns:a16="http://schemas.microsoft.com/office/drawing/2014/main" id="{A219F0BA-71F5-BA11-CCBD-9327897B98CC}"/>
-              </a:ext>
-            </a:extLst>
-          </p:cNvPr>
-          <p:cNvSpPr>
-            <a:spLocks noGrp="1"/>
-          </p:cNvSpPr>
-          <p:nvPr>
-            <p:ph type="body" sz="quarter" idx="10"/>
-          </p:nvPr>
-        </p:nvSpPr>
-        <p:spPr>
-          <a:xfrm>
-            <a:off x="0" y="820290"/>
-            <a:ext cx="5878224" cy="638175"/>
-          </a:xfrm>
-        </p:spPr>
-        <p:txBody>
-          <a:bodyPr/>
-          <a:lstStyle/>
-          <a:p>
-            <a:r>
-              <a:rPr lang="en-US" altLang="zh-CN" sz="2800" dirty="0"/>
-              <a:t>Design</a:t>
-            </a:r>
-            <a:endParaRPr lang="zh-CN" altLang="en-US" sz="2800" dirty="0"/>
-          </a:p>
-        </p:txBody>
-      </p:sp>
-      <p:sp>
-        <p:nvSpPr>
-          <p:cNvPr id="204" name="TextBox 203"/>
-          <p:cNvSpPr txBox="1"/>
-          <p:nvPr/>
-        </p:nvSpPr>
-        <p:spPr>
-          <a:xfrm>
-            <a:off x="640080" y="1508760"/>
-            <a:ext cx="10881360" cy="914400"/>
-          </a:xfrm>
-          <a:prstGeom prst="rect">
-            <a:avLst/>
-          </a:prstGeom>
-          <a:noFill/>
-        </p:spPr>
-        <p:txBody>
-          <a:bodyPr wrap="square">
-            <a:spAutoFit/>
-          </a:bodyPr>
-          <a:lstStyle/>
-          <a:p>
-            <a:pPr>
-              <a:defRPr sz="1350" b="1"/>
-            </a:pPr>
-            <a:r>
-              <a:t>• Five layers, 2 300 cases, none seen in training:</a:t>
-            </a:r>
-          </a:p>
-          <a:p>
-            <a:pPr>
-              <a:defRPr sz="1200" b="0"/>
-            </a:pPr>
-            <a:r>
-              <a:t>   – L1 same-distribution — 800 fresh cases (trained ODs, new δ / task mixes)</a:t>
-            </a:r>
-          </a:p>
-          <a:p>
-            <a:pPr>
-              <a:defRPr sz="1200" b="0"/>
-            </a:pPr>
-            <a:r>
-              <a:t>   – L2 OD ZERO-SHOT — 400 cases on 4 OD pairs never trained (G1→G5, G6→G2, G4→G8, G7→G3)</a:t>
-            </a:r>
-          </a:p>
-          <a:p>
-            <a:pPr>
-              <a:defRPr sz="1200" b="0"/>
-            </a:pPr>
-            <a:r>
-              <a:t>   – L3 fleet extrapolation — 400 cases with V ∈ {5, 8}, trained on {2,3,4,6}</a:t>
-            </a:r>
-          </a:p>
-          <a:p>
-            <a:pPr>
-              <a:defRPr sz="1200" b="0"/>
-            </a:pPr>
-            <a:r>
-              <a:t>   – L4a UNSEEN budget, interpolation — 400 cases at ρ ∈ {1.25, 1.75}</a:t>
-            </a:r>
-          </a:p>
-          <a:p>
-            <a:pPr>
-              <a:defRPr sz="1200" b="0"/>
-            </a:pPr>
-            <a:r>
-              <a:t>   – L4b UNSEEN budget, extrapolation — 300 cases at ρ = 4.0, beyond the trained range</a:t>
-            </a:r>
-          </a:p>
-          <a:p>
-            <a:pPr>
-              <a:defRPr sz="1350" b="1"/>
-            </a:pPr>
-            <a:r>
-              <a:t>• Plus the RESPONSE CURVE: 60 fixed instances re-solved at every ρ by both Gurobi and the model — did it learn the budget as a continuous quantity or memorise four settings?</a:t>
-            </a:r>
-          </a:p>
-          <a:p>
-            <a:pPr>
-              <a:defRPr sz="1350" b="0"/>
-            </a:pPr>
-            <a:r>
-              <a:t>• Metrics: feasibility rate · objective gap vs Gurobi (absolute + relative) · fraction matching or beating Gurobi · inference time · per-case CSV. 3 seeds, mean ± std</a:t>
-            </a:r>
-          </a:p>
-          <a:p>
-            <a:pPr>
-              <a:defRPr sz="1350" b="0"/>
-            </a:pPr>
-            <a:r>
-              <a:t>• Tuning used a validation slice of the training shard only; every reported number is from held-out shards</a:t>
-            </a:r>
-          </a:p>
-        </p:txBody>
-      </p:sp>
-    </p:spTree>
-  </p:cSld>
-  <p:clrMapOvr>
-    <a:masterClrMapping/>
-  </p:clrMapOvr>
-</p:sld>
-</file>
-
 <file path=ppt/slides/slide3.xml><?xml version="1.0" encoding="utf-8"?>
 <p:sld xmlns:a="http://schemas.openxmlformats.org/drawingml/2006/main" xmlns:r="http://schemas.openxmlformats.org/officeDocument/2006/relationships" xmlns:p="http://schemas.openxmlformats.org/presentationml/2006/main">
   <p:cSld>
@@ -16719,6 +16689,360 @@
           <a:p>
             <a:r>
               <a:rPr lang="en-US" altLang="zh-CN" dirty="0"/>
+              <a:t>Data</a:t>
+            </a:r>
+            <a:endParaRPr lang="zh-CN" altLang="en-US" dirty="0"/>
+          </a:p>
+        </p:txBody>
+      </p:sp>
+      <p:sp>
+        <p:nvSpPr>
+          <p:cNvPr id="203" name="文本占位符 5">
+            <a:extLst>
+              <a:ext uri="{FF2B5EF4-FFF2-40B4-BE49-F238E27FC236}">
+                <a16:creationId xmlns:a16="http://schemas.microsoft.com/office/drawing/2014/main" id="{A219F0BA-71F5-BA11-CCBD-9327897B98CC}"/>
+              </a:ext>
+            </a:extLst>
+          </p:cNvPr>
+          <p:cNvSpPr>
+            <a:spLocks noGrp="1"/>
+          </p:cNvSpPr>
+          <p:nvPr>
+            <p:ph type="body" sz="quarter" idx="10"/>
+          </p:nvPr>
+        </p:nvSpPr>
+        <p:spPr>
+          <a:xfrm>
+            <a:off x="0" y="820290"/>
+            <a:ext cx="5878224" cy="638175"/>
+          </a:xfrm>
+        </p:spPr>
+        <p:txBody>
+          <a:bodyPr/>
+          <a:lstStyle/>
+          <a:p>
+            <a:r>
+              <a:rPr lang="en-US" altLang="zh-CN" sz="2800" dirty="0"/>
+              <a:t>Label set</a:t>
+            </a:r>
+            <a:endParaRPr lang="zh-CN" altLang="en-US" sz="2800" dirty="0"/>
+          </a:p>
+        </p:txBody>
+      </p:sp>
+      <p:sp>
+        <p:nvSpPr>
+          <p:cNvPr id="204" name="TextBox 203"/>
+          <p:cNvSpPr txBox="1"/>
+          <p:nvPr/>
+        </p:nvSpPr>
+        <p:spPr>
+          <a:xfrm>
+            <a:off x="640080" y="1508760"/>
+            <a:ext cx="10881360" cy="914400"/>
+          </a:xfrm>
+          <a:prstGeom prst="rect">
+            <a:avLst/>
+          </a:prstGeom>
+          <a:noFill/>
+        </p:spPr>
+        <p:txBody>
+          <a:bodyPr wrap="square">
+            <a:spAutoFit/>
+          </a:bodyPr>
+          <a:lstStyle/>
+          <a:p>
+            <a:pPr>
+              <a:defRPr sz="1350" b="1"/>
+            </a:pPr>
+            <a:r>
+              <a:t>• 10 780 Gurobi labels · 0 errors · 0 solves hit the 60 s cap · 0.90 s mean per case (tight budgets prune the time-expanded graph → labelling ~30× faster than the full-horizon farm) · ~17 min on 15 workers, fully resumable</a:t>
+            </a:r>
+          </a:p>
+          <a:p>
+            <a:pPr>
+              <a:defRPr sz="1350" b="1"/>
+            </a:pPr>
+            <a:r>
+              <a:t>• Shards:</a:t>
+            </a:r>
+          </a:p>
+          <a:p>
+            <a:pPr>
+              <a:defRPr sz="1200" b="0"/>
+            </a:pPr>
+            <a:r>
+              <a:t>   – train 8 000 · same-distribution test 800</a:t>
+            </a:r>
+          </a:p>
+          <a:p>
+            <a:pPr>
+              <a:defRPr sz="1200" b="0"/>
+            </a:pPr>
+            <a:r>
+              <a:t>   – OD zero-shot 400 (4 gate pairs never trained) · fleet extrapolation 400 (V ∈ {5,8})</a:t>
+            </a:r>
+          </a:p>
+          <a:p>
+            <a:pPr>
+              <a:defRPr sz="1200" b="0"/>
+            </a:pPr>
+            <a:r>
+              <a:t>   – UNSEEN-budget interpolation 400 (ρ ∈ {1.25, 1.75}) · extrapolation 300 (ρ = 4.0)</a:t>
+            </a:r>
+          </a:p>
+          <a:p>
+            <a:pPr>
+              <a:defRPr sz="1200" b="0"/>
+            </a:pPr>
+            <a:r>
+              <a:t>   – response curve: 60 fixed instances × 8 ρ values, re-solved by Gurobi at every ρ</a:t>
+            </a:r>
+          </a:p>
+          <a:p>
+            <a:pPr>
+              <a:defRPr sz="1350" b="0"/>
+            </a:pPr>
+            <a:r>
+              <a:t>• Trained ρ anchors {1.0, 1.5, 2.0, 3.0}; the three held-out ρ values appear in NO training label</a:t>
+            </a:r>
+          </a:p>
+          <a:p>
+            <a:pPr>
+              <a:defRPr sz="1350" b="0"/>
+            </a:pPr>
+            <a:r>
+              <a:t>• Every label passes two checks at write time: flow-decomposed objective ≡ Gurobi ObjVal (1e-6) and every per-vehicle deadline re-validated</a:t>
+            </a:r>
+          </a:p>
+        </p:txBody>
+      </p:sp>
+    </p:spTree>
+  </p:cSld>
+  <p:clrMapOvr>
+    <a:masterClrMapping/>
+  </p:clrMapOvr>
+</p:sld>
+</file>
+
+<file path=ppt/slides/slide31.xml><?xml version="1.0" encoding="utf-8"?>
+<p:sld xmlns:a="http://schemas.openxmlformats.org/drawingml/2006/main" xmlns:p="http://schemas.openxmlformats.org/presentationml/2006/main" xmlns:r="http://schemas.openxmlformats.org/officeDocument/2006/relationships">
+  <p:cSld>
+    <p:spTree>
+      <p:nvGrpSpPr>
+        <p:cNvPr id="1" name=""/>
+        <p:cNvGrpSpPr/>
+        <p:nvPr/>
+      </p:nvGrpSpPr>
+      <p:grpSpPr/>
+      <p:sp>
+        <p:nvSpPr>
+          <p:cNvPr id="7" name="文本占位符 6">
+            <a:extLst>
+              <a:ext uri="{FF2B5EF4-FFF2-40B4-BE49-F238E27FC236}">
+                <a16:creationId xmlns:a16="http://schemas.microsoft.com/office/drawing/2014/main" id="{33AE8DB3-4C29-0DE3-EB73-8D2BBFBB8CBF}"/>
+              </a:ext>
+            </a:extLst>
+          </p:cNvPr>
+          <p:cNvSpPr>
+            <a:spLocks noGrp="1"/>
+          </p:cNvSpPr>
+          <p:nvPr>
+            <p:ph type="body" sz="quarter" idx="11"/>
+          </p:nvPr>
+        </p:nvSpPr>
+        <p:spPr>
+          <a:xfrm>
+            <a:off x="336550" y="58738"/>
+            <a:ext cx="5759450" cy="622300"/>
+          </a:xfrm>
+        </p:spPr>
+        <p:txBody>
+          <a:bodyPr/>
+          <a:lstStyle/>
+          <a:p>
+            <a:r>
+              <a:rPr lang="en-US" altLang="zh-CN" dirty="0"/>
+              <a:t>Evaluation</a:t>
+            </a:r>
+            <a:endParaRPr lang="zh-CN" altLang="en-US" dirty="0"/>
+          </a:p>
+        </p:txBody>
+      </p:sp>
+      <p:sp>
+        <p:nvSpPr>
+          <p:cNvPr id="203" name="文本占位符 5">
+            <a:extLst>
+              <a:ext uri="{FF2B5EF4-FFF2-40B4-BE49-F238E27FC236}">
+                <a16:creationId xmlns:a16="http://schemas.microsoft.com/office/drawing/2014/main" id="{A219F0BA-71F5-BA11-CCBD-9327897B98CC}"/>
+              </a:ext>
+            </a:extLst>
+          </p:cNvPr>
+          <p:cNvSpPr>
+            <a:spLocks noGrp="1"/>
+          </p:cNvSpPr>
+          <p:nvPr>
+            <p:ph type="body" sz="quarter" idx="10"/>
+          </p:nvPr>
+        </p:nvSpPr>
+        <p:spPr>
+          <a:xfrm>
+            <a:off x="0" y="820290"/>
+            <a:ext cx="5878224" cy="638175"/>
+          </a:xfrm>
+        </p:spPr>
+        <p:txBody>
+          <a:bodyPr/>
+          <a:lstStyle/>
+          <a:p>
+            <a:r>
+              <a:rPr lang="en-US" altLang="zh-CN" sz="2800" dirty="0"/>
+              <a:t>Design</a:t>
+            </a:r>
+            <a:endParaRPr lang="zh-CN" altLang="en-US" sz="2800" dirty="0"/>
+          </a:p>
+        </p:txBody>
+      </p:sp>
+      <p:sp>
+        <p:nvSpPr>
+          <p:cNvPr id="204" name="TextBox 203"/>
+          <p:cNvSpPr txBox="1"/>
+          <p:nvPr/>
+        </p:nvSpPr>
+        <p:spPr>
+          <a:xfrm>
+            <a:off x="640080" y="1508760"/>
+            <a:ext cx="10881360" cy="914400"/>
+          </a:xfrm>
+          <a:prstGeom prst="rect">
+            <a:avLst/>
+          </a:prstGeom>
+          <a:noFill/>
+        </p:spPr>
+        <p:txBody>
+          <a:bodyPr wrap="square">
+            <a:spAutoFit/>
+          </a:bodyPr>
+          <a:lstStyle/>
+          <a:p>
+            <a:pPr>
+              <a:defRPr sz="1350" b="1"/>
+            </a:pPr>
+            <a:r>
+              <a:t>• Five layers, 2 300 cases, none seen in training:</a:t>
+            </a:r>
+          </a:p>
+          <a:p>
+            <a:pPr>
+              <a:defRPr sz="1200" b="0"/>
+            </a:pPr>
+            <a:r>
+              <a:t>   – L1 same-distribution — 800 fresh cases (trained ODs, new δ / task mixes)</a:t>
+            </a:r>
+          </a:p>
+          <a:p>
+            <a:pPr>
+              <a:defRPr sz="1200" b="0"/>
+            </a:pPr>
+            <a:r>
+              <a:t>   – L2 OD ZERO-SHOT — 400 cases on 4 OD pairs never trained (G1→G5, G6→G2, G4→G8, G7→G3)</a:t>
+            </a:r>
+          </a:p>
+          <a:p>
+            <a:pPr>
+              <a:defRPr sz="1200" b="0"/>
+            </a:pPr>
+            <a:r>
+              <a:t>   – L3 fleet extrapolation — 400 cases with V ∈ {5, 8}, trained on {2,3,4,6}</a:t>
+            </a:r>
+          </a:p>
+          <a:p>
+            <a:pPr>
+              <a:defRPr sz="1200" b="0"/>
+            </a:pPr>
+            <a:r>
+              <a:t>   – L4a UNSEEN budget, interpolation — 400 cases at ρ ∈ {1.25, 1.75}</a:t>
+            </a:r>
+          </a:p>
+          <a:p>
+            <a:pPr>
+              <a:defRPr sz="1200" b="0"/>
+            </a:pPr>
+            <a:r>
+              <a:t>   – L4b UNSEEN budget, extrapolation — 300 cases at ρ = 4.0, beyond the trained range</a:t>
+            </a:r>
+          </a:p>
+          <a:p>
+            <a:pPr>
+              <a:defRPr sz="1350" b="1"/>
+            </a:pPr>
+            <a:r>
+              <a:t>• Plus the RESPONSE CURVE: 60 fixed instances re-solved at every ρ by both Gurobi and the model — did it learn the budget as a continuous quantity or memorise four settings?</a:t>
+            </a:r>
+          </a:p>
+          <a:p>
+            <a:pPr>
+              <a:defRPr sz="1350" b="0"/>
+            </a:pPr>
+            <a:r>
+              <a:t>• Metrics: feasibility rate · objective gap vs Gurobi (absolute + relative) · fraction matching or beating Gurobi · inference time · per-case CSV. 3 seeds, mean ± std</a:t>
+            </a:r>
+          </a:p>
+          <a:p>
+            <a:pPr>
+              <a:defRPr sz="1350" b="0"/>
+            </a:pPr>
+            <a:r>
+              <a:t>• Tuning used a validation slice of the training shard only; every reported number is from held-out shards</a:t>
+            </a:r>
+          </a:p>
+        </p:txBody>
+      </p:sp>
+    </p:spTree>
+  </p:cSld>
+  <p:clrMapOvr>
+    <a:masterClrMapping/>
+  </p:clrMapOvr>
+</p:sld>
+</file>
+
+<file path=ppt/slides/slide32.xml><?xml version="1.0" encoding="utf-8"?>
+<p:sld xmlns:a="http://schemas.openxmlformats.org/drawingml/2006/main" xmlns:p="http://schemas.openxmlformats.org/presentationml/2006/main" xmlns:r="http://schemas.openxmlformats.org/officeDocument/2006/relationships">
+  <p:cSld>
+    <p:spTree>
+      <p:nvGrpSpPr>
+        <p:cNvPr id="1" name=""/>
+        <p:cNvGrpSpPr/>
+        <p:nvPr/>
+      </p:nvGrpSpPr>
+      <p:grpSpPr/>
+      <p:sp>
+        <p:nvSpPr>
+          <p:cNvPr id="7" name="文本占位符 6">
+            <a:extLst>
+              <a:ext uri="{FF2B5EF4-FFF2-40B4-BE49-F238E27FC236}">
+                <a16:creationId xmlns:a16="http://schemas.microsoft.com/office/drawing/2014/main" id="{33AE8DB3-4C29-0DE3-EB73-8D2BBFBB8CBF}"/>
+              </a:ext>
+            </a:extLst>
+          </p:cNvPr>
+          <p:cNvSpPr>
+            <a:spLocks noGrp="1"/>
+          </p:cNvSpPr>
+          <p:nvPr>
+            <p:ph type="body" sz="quarter" idx="11"/>
+          </p:nvPr>
+        </p:nvSpPr>
+        <p:spPr>
+          <a:xfrm>
+            <a:off x="336550" y="58738"/>
+            <a:ext cx="5759450" cy="622300"/>
+          </a:xfrm>
+        </p:spPr>
+        <p:txBody>
+          <a:bodyPr/>
+          <a:lstStyle/>
+          <a:p>
+            <a:r>
+              <a:rPr lang="en-US" altLang="zh-CN" dirty="0"/>
               <a:t>Results</a:t>
             </a:r>
             <a:endParaRPr lang="zh-CN" altLang="en-US" dirty="0"/>
@@ -16830,7 +17154,7 @@
 </p:sld>
 </file>
 
-<file path=ppt/slides/slide31.xml><?xml version="1.0" encoding="utf-8"?>
+<file path=ppt/slides/slide33.xml><?xml version="1.0" encoding="utf-8"?>
 <p:sld xmlns:a="http://schemas.openxmlformats.org/drawingml/2006/main" xmlns:p="http://schemas.openxmlformats.org/presentationml/2006/main" xmlns:r="http://schemas.openxmlformats.org/officeDocument/2006/relationships">
   <p:cSld>
     <p:spTree>
@@ -16971,7 +17295,7 @@
 </p:sld>
 </file>
 
-<file path=ppt/slides/slide32.xml><?xml version="1.0" encoding="utf-8"?>
+<file path=ppt/slides/slide34.xml><?xml version="1.0" encoding="utf-8"?>
 <p:sld xmlns:a="http://schemas.openxmlformats.org/drawingml/2006/main" xmlns:p="http://schemas.openxmlformats.org/presentationml/2006/main" xmlns:r="http://schemas.openxmlformats.org/officeDocument/2006/relationships">
   <p:cSld>
     <p:spTree>

</xml_diff>